<commit_message>
docs: refresh weeks 04-11 course materials
Restructure docs/05,07 lab.md task numbering, trim redundant docs/06
PDF exports and duplicate docs/07,08 slide decks, expand docs/11
README/lab/lecture_notes with a boundary Q&A section, and add new
docs/08,09 reference slide decks.

Co-Authored-By: Claude Sonnet 5 <noreply@anthropic.com>
</commit_message>
<xml_diff>
--- a/docs/06/06_abi_registers.pptx
+++ b/docs/06/06_abi_registers.pptx
@@ -5,7 +5,7 @@
     <p:sldMasterId id="2147483648" r:id="rId1"/>
   </p:sldMasterIdLst>
   <p:notesMasterIdLst>
-    <p:notesMasterId r:id="rId43"/>
+    <p:notesMasterId r:id="rId44"/>
   </p:notesMasterIdLst>
   <p:sldIdLst>
     <p:sldId id="256" r:id="rId2"/>
@@ -46,9 +46,10 @@
     <p:sldId id="279" r:id="rId37"/>
     <p:sldId id="283" r:id="rId38"/>
     <p:sldId id="284" r:id="rId39"/>
-    <p:sldId id="280" r:id="rId40"/>
-    <p:sldId id="281" r:id="rId41"/>
-    <p:sldId id="282" r:id="rId42"/>
+    <p:sldId id="298" r:id="rId40"/>
+    <p:sldId id="280" r:id="rId41"/>
+    <p:sldId id="281" r:id="rId42"/>
+    <p:sldId id="282" r:id="rId43"/>
   </p:sldIdLst>
   <p:sldSz cx="12192000" cy="6858000"/>
   <p:notesSz cx="6858000" cy="12192000"/>
@@ -3917,7 +3918,7 @@
                 <a:tabLst/>
                 <a:defRPr/>
               </a:pPr>
-              <a:t>39</a:t>
+              <a:t>40</a:t>
             </a:fld>
             <a:endParaRPr kumimoji="0" lang="en-US" sz="1800" b="0" i="0" u="none" strike="noStrike" kern="1200" cap="none" spc="0" normalizeH="0" baseline="0" noProof="0">
               <a:ln>
@@ -4145,7 +4146,7 @@
                 <a:tabLst/>
                 <a:defRPr/>
               </a:pPr>
-              <a:t>40</a:t>
+              <a:t>41</a:t>
             </a:fld>
             <a:endParaRPr kumimoji="0" lang="en-US" sz="1800" b="0" i="0" u="none" strike="noStrike" kern="1200" cap="none" spc="0" normalizeH="0" baseline="0" noProof="0">
               <a:ln>
@@ -4289,7 +4290,7 @@
                 <a:tabLst/>
                 <a:defRPr/>
               </a:pPr>
-              <a:t>41</a:t>
+              <a:t>42</a:t>
             </a:fld>
             <a:endParaRPr kumimoji="0" lang="en-US" sz="1800" b="0" i="0" u="none" strike="noStrike" kern="1200" cap="none" spc="0" normalizeH="0" baseline="0" noProof="0">
               <a:ln>
@@ -30701,14 +30702,6 @@
 <file path=ppt/slides/slide39.xml><?xml version="1.0" encoding="utf-8"?>
 <p:sld xmlns:a="http://schemas.openxmlformats.org/drawingml/2006/main" xmlns:r="http://schemas.openxmlformats.org/officeDocument/2006/relationships" xmlns:p="http://schemas.openxmlformats.org/presentationml/2006/main">
   <p:cSld>
-    <p:bg>
-      <p:bgPr>
-        <a:solidFill>
-          <a:srgbClr val="F7FAFC"/>
-        </a:solidFill>
-        <a:effectLst/>
-      </p:bgPr>
-    </p:bg>
     <p:spTree>
       <p:nvGrpSpPr>
         <p:cNvPr id="1" name=""/>
@@ -30766,54 +30759,21 @@
           <a:bodyPr wrap="square" rtlCol="0" anchor="ctr"/>
           <a:lstStyle/>
           <a:p>
-            <a:pPr marL="0" marR="0" lvl="0" indent="0" algn="ctr" defTabSz="914400" rtl="0" eaLnBrk="1" fontAlgn="auto" latinLnBrk="0" hangingPunct="1">
-              <a:lnSpc>
-                <a:spcPct val="100000"/>
-              </a:lnSpc>
-              <a:spcBef>
-                <a:spcPts val="0"/>
-              </a:spcBef>
-              <a:spcAft>
-                <a:spcPts val="0"/>
-              </a:spcAft>
-              <a:buClrTx/>
-              <a:buSzTx/>
-              <a:buFontTx/>
-              <a:buNone/>
-              <a:tabLst/>
-              <a:defRPr/>
-            </a:pPr>
-            <a:r>
-              <a:rPr kumimoji="0" lang="en-US" sz="2400" b="1" i="0" u="none" strike="noStrike" kern="1200" cap="none" spc="0" normalizeH="0" baseline="0" noProof="0" dirty="0">
-                <a:ln>
-                  <a:noFill/>
-                </a:ln>
+            <a:pPr marL="0" indent="0" algn="ctr">
+              <a:buNone/>
+            </a:pPr>
+            <a:r>
+              <a:rPr lang="en-US" sz="2400" b="1" dirty="0">
                 <a:solidFill>
                   <a:srgbClr val="FFFFFF"/>
                 </a:solidFill>
-                <a:effectLst/>
-                <a:uLnTx/>
-                <a:uFillTx/>
                 <a:latin typeface="Calibri" pitchFamily="34" charset="0"/>
                 <a:ea typeface="Calibri" pitchFamily="34" charset="-122"/>
                 <a:cs typeface="Calibri" pitchFamily="34" charset="-120"/>
               </a:rPr>
-              <a:t>5.5 · 系统调用约定</a:t>
-            </a:r>
-            <a:endParaRPr kumimoji="0" lang="en-US" sz="2400" b="0" i="0" u="none" strike="noStrike" kern="1200" cap="none" spc="0" normalizeH="0" baseline="0" noProof="0" dirty="0">
-              <a:ln>
-                <a:noFill/>
-              </a:ln>
-              <a:solidFill>
-                <a:prstClr val="black"/>
-              </a:solidFill>
-              <a:effectLst/>
-              <a:uLnTx/>
-              <a:uFillTx/>
-              <a:latin typeface="Calibri" panose="020F0502020204030204"/>
-              <a:ea typeface="+mn-ea"/>
-              <a:cs typeface="+mn-cs"/>
-            </a:endParaRPr>
+              <a:t>5.4 · 叶子函数与非叶子函数（补充）</a:t>
+            </a:r>
+            <a:endParaRPr lang="en-US" sz="2400" dirty="0"/>
           </a:p>
         </p:txBody>
       </p:sp>
@@ -30825,8 +30785,8 @@
         </p:nvSpPr>
         <p:spPr>
           <a:xfrm>
-            <a:off x="457200" y="932688"/>
-            <a:ext cx="11247120" cy="640080"/>
+            <a:off x="457200" y="5678424"/>
+            <a:ext cx="5473560" cy="640080"/>
           </a:xfrm>
           <a:prstGeom prst="rect">
             <a:avLst/>
@@ -30838,54 +30798,21 @@
           <a:bodyPr wrap="square" rtlCol="0" anchor="ctr"/>
           <a:lstStyle/>
           <a:p>
-            <a:pPr marL="0" marR="0" lvl="0" indent="0" algn="l" defTabSz="914400" rtl="0" eaLnBrk="1" fontAlgn="auto" latinLnBrk="0" hangingPunct="1">
-              <a:lnSpc>
-                <a:spcPct val="100000"/>
-              </a:lnSpc>
-              <a:spcBef>
-                <a:spcPts val="0"/>
-              </a:spcBef>
-              <a:spcAft>
-                <a:spcPts val="0"/>
-              </a:spcAft>
-              <a:buClrTx/>
-              <a:buSzTx/>
-              <a:buFontTx/>
-              <a:buNone/>
-              <a:tabLst/>
-              <a:defRPr/>
-            </a:pPr>
-            <a:r>
-              <a:rPr kumimoji="0" lang="en-US" sz="2800" b="1" i="0" u="none" strike="noStrike" kern="1200" cap="none" spc="0" normalizeH="0" baseline="0" noProof="0" dirty="0">
-                <a:ln>
-                  <a:noFill/>
-                </a:ln>
+            <a:pPr marL="0" indent="0" algn="l">
+              <a:buNone/>
+            </a:pPr>
+            <a:r>
+              <a:rPr lang="en-US" sz="2800" b="1" dirty="0">
                 <a:solidFill>
                   <a:srgbClr val="16222E"/>
                 </a:solidFill>
-                <a:effectLst/>
-                <a:uLnTx/>
-                <a:uFillTx/>
                 <a:latin typeface="Cambria" pitchFamily="34" charset="0"/>
                 <a:ea typeface="Cambria" pitchFamily="34" charset="-122"/>
                 <a:cs typeface="Cambria" pitchFamily="34" charset="-120"/>
               </a:rPr>
-              <a:t>系统调用约定：a7 传号，a0~a6 传参</a:t>
-            </a:r>
-            <a:endParaRPr kumimoji="0" lang="en-US" sz="2800" b="0" i="0" u="none" strike="noStrike" kern="1200" cap="none" spc="0" normalizeH="0" baseline="0" noProof="0" dirty="0">
-              <a:ln>
-                <a:noFill/>
-              </a:ln>
-              <a:solidFill>
-                <a:prstClr val="black"/>
-              </a:solidFill>
-              <a:effectLst/>
-              <a:uLnTx/>
-              <a:uFillTx/>
-              <a:latin typeface="Calibri" panose="020F0502020204030204"/>
-              <a:ea typeface="+mn-ea"/>
-              <a:cs typeface="+mn-cs"/>
-            </a:endParaRPr>
+              <a:t>叶子函数 vs 非叶子函数：谁必须保存 ra？</a:t>
+            </a:r>
+            <a:endParaRPr lang="en-US" sz="2800" dirty="0"/>
           </a:p>
         </p:txBody>
       </p:sp>
@@ -30897,27 +30824,336 @@
         </p:nvSpPr>
         <p:spPr>
           <a:xfrm>
-            <a:off x="457200" y="1828800"/>
-            <a:ext cx="11247120" cy="914400"/>
+            <a:off x="457200" y="1014984"/>
+            <a:ext cx="11247120" cy="1453896"/>
           </a:xfrm>
           <a:prstGeom prst="roundRect">
             <a:avLst>
-              <a:gd name="adj" fmla="val 9000"/>
+              <a:gd name="adj" fmla="val 11765"/>
             </a:avLst>
           </a:prstGeom>
           <a:solidFill>
-            <a:srgbClr val="FFFFFF"/>
+            <a:srgbClr val="EAF3F8"/>
           </a:solidFill>
-          <a:ln w="12700">
-            <a:solidFill>
-              <a:srgbClr val="E1E9EF"/>
-            </a:solidFill>
-            <a:prstDash val="solid"/>
-          </a:ln>
+          <a:ln/>
+        </p:spPr>
+      </p:sp>
+      <p:sp>
+        <p:nvSpPr>
+          <p:cNvPr id="6" name="Text 4"/>
+          <p:cNvSpPr/>
+          <p:nvPr/>
+        </p:nvSpPr>
+        <p:spPr>
+          <a:xfrm>
+            <a:off x="457200" y="1014984"/>
+            <a:ext cx="11369040" cy="1453896"/>
+          </a:xfrm>
+          <a:prstGeom prst="rect">
+            <a:avLst/>
+          </a:prstGeom>
+          <a:noFill/>
+          <a:ln/>
+        </p:spPr>
+        <p:txBody>
+          <a:bodyPr wrap="square" rtlCol="0" anchor="ctr"/>
+          <a:lstStyle/>
+          <a:p>
+            <a:pPr marL="0" indent="0">
+              <a:lnSpc>
+                <a:spcPct val="120000"/>
+              </a:lnSpc>
+              <a:buNone/>
+            </a:pPr>
+            <a:r>
+              <a:rPr lang="en-US" sz="2400" dirty="0" err="1">
+                <a:solidFill>
+                  <a:srgbClr val="16222E"/>
+                </a:solidFill>
+                <a:latin typeface="Calibri" pitchFamily="34" charset="0"/>
+                <a:ea typeface="Calibri" pitchFamily="34" charset="-122"/>
+                <a:cs typeface="Calibri" pitchFamily="34" charset="-120"/>
+              </a:rPr>
+              <a:t>内部</a:t>
+            </a:r>
+            <a:r>
+              <a:rPr lang="en-US" sz="2400" dirty="0" err="1">
+                <a:solidFill>
+                  <a:srgbClr val="FF0000"/>
+                </a:solidFill>
+                <a:latin typeface="Calibri" pitchFamily="34" charset="0"/>
+                <a:ea typeface="Calibri" pitchFamily="34" charset="-122"/>
+                <a:cs typeface="Calibri" pitchFamily="34" charset="-120"/>
+              </a:rPr>
+              <a:t>不调用</a:t>
+            </a:r>
+            <a:r>
+              <a:rPr lang="en-US" sz="2400" dirty="0" err="1">
+                <a:solidFill>
+                  <a:srgbClr val="16222E"/>
+                </a:solidFill>
+                <a:latin typeface="Calibri" pitchFamily="34" charset="0"/>
+                <a:ea typeface="Calibri" pitchFamily="34" charset="-122"/>
+                <a:cs typeface="Calibri" pitchFamily="34" charset="-120"/>
+              </a:rPr>
+              <a:t>其他函数的叫</a:t>
+            </a:r>
+            <a:r>
+              <a:rPr lang="en-US" sz="2400" dirty="0" err="1">
+                <a:solidFill>
+                  <a:srgbClr val="FF0000"/>
+                </a:solidFill>
+                <a:latin typeface="Calibri" pitchFamily="34" charset="0"/>
+                <a:ea typeface="Calibri" pitchFamily="34" charset="-122"/>
+                <a:cs typeface="Calibri" pitchFamily="34" charset="-120"/>
+              </a:rPr>
+              <a:t>叶子函数</a:t>
+            </a:r>
+            <a:r>
+              <a:rPr lang="zh-CN" altLang="en-US" sz="2400" dirty="0">
+                <a:solidFill>
+                  <a:srgbClr val="16222E"/>
+                </a:solidFill>
+                <a:latin typeface="Calibri" pitchFamily="34" charset="0"/>
+                <a:ea typeface="Calibri" pitchFamily="34" charset="-122"/>
+                <a:cs typeface="Calibri" pitchFamily="34" charset="-120"/>
+              </a:rPr>
+              <a:t>：</a:t>
+            </a:r>
+            <a:r>
+              <a:rPr lang="en-US" sz="2400" dirty="0" err="1">
+                <a:solidFill>
+                  <a:srgbClr val="16222E"/>
+                </a:solidFill>
+                <a:latin typeface="Calibri" pitchFamily="34" charset="0"/>
+                <a:ea typeface="Calibri" pitchFamily="34" charset="-122"/>
+                <a:cs typeface="Calibri" pitchFamily="34" charset="-120"/>
+              </a:rPr>
+              <a:t>ra</a:t>
+            </a:r>
+            <a:r>
+              <a:rPr lang="en-US" sz="2400" dirty="0">
+                <a:solidFill>
+                  <a:srgbClr val="16222E"/>
+                </a:solidFill>
+                <a:latin typeface="Calibri" pitchFamily="34" charset="0"/>
+                <a:ea typeface="Calibri" pitchFamily="34" charset="-122"/>
+                <a:cs typeface="Calibri" pitchFamily="34" charset="-120"/>
+              </a:rPr>
+              <a:t> </a:t>
+            </a:r>
+            <a:r>
+              <a:rPr lang="en-US" sz="2400" dirty="0" err="1">
+                <a:solidFill>
+                  <a:srgbClr val="16222E"/>
+                </a:solidFill>
+                <a:latin typeface="Calibri" pitchFamily="34" charset="0"/>
+                <a:ea typeface="Calibri" pitchFamily="34" charset="-122"/>
+                <a:cs typeface="Calibri" pitchFamily="34" charset="-120"/>
+              </a:rPr>
+              <a:t>全程不会被覆盖，</a:t>
+            </a:r>
+            <a:r>
+              <a:rPr lang="en-US" sz="2400" dirty="0" err="1">
+                <a:solidFill>
+                  <a:srgbClr val="FF0000"/>
+                </a:solidFill>
+                <a:latin typeface="Calibri" pitchFamily="34" charset="0"/>
+                <a:ea typeface="Calibri" pitchFamily="34" charset="-122"/>
+                <a:cs typeface="Calibri" pitchFamily="34" charset="-120"/>
+              </a:rPr>
+              <a:t>可直接</a:t>
+            </a:r>
+            <a:r>
+              <a:rPr lang="en-US" sz="2400" dirty="0">
+                <a:solidFill>
+                  <a:srgbClr val="FF0000"/>
+                </a:solidFill>
+                <a:latin typeface="Calibri" pitchFamily="34" charset="0"/>
+                <a:ea typeface="Calibri" pitchFamily="34" charset="-122"/>
+                <a:cs typeface="Calibri" pitchFamily="34" charset="-120"/>
+              </a:rPr>
+              <a:t> jr ra </a:t>
+            </a:r>
+            <a:r>
+              <a:rPr lang="en-US" sz="2400" dirty="0" err="1">
+                <a:solidFill>
+                  <a:srgbClr val="FF0000"/>
+                </a:solidFill>
+                <a:latin typeface="Calibri" pitchFamily="34" charset="0"/>
+                <a:ea typeface="Calibri" pitchFamily="34" charset="-122"/>
+                <a:cs typeface="Calibri" pitchFamily="34" charset="-120"/>
+              </a:rPr>
+              <a:t>返回</a:t>
+            </a:r>
+            <a:r>
+              <a:rPr lang="en-US" sz="2400" dirty="0">
+                <a:solidFill>
+                  <a:srgbClr val="16222E"/>
+                </a:solidFill>
+                <a:latin typeface="Calibri" pitchFamily="34" charset="0"/>
+                <a:ea typeface="Calibri" pitchFamily="34" charset="-122"/>
+                <a:cs typeface="Calibri" pitchFamily="34" charset="-120"/>
+              </a:rPr>
+              <a:t>；</a:t>
+            </a:r>
+          </a:p>
+          <a:p>
+            <a:pPr marL="0" indent="0">
+              <a:lnSpc>
+                <a:spcPct val="120000"/>
+              </a:lnSpc>
+              <a:buNone/>
+            </a:pPr>
+            <a:r>
+              <a:rPr lang="en-US" sz="2400" dirty="0" err="1">
+                <a:solidFill>
+                  <a:srgbClr val="16222E"/>
+                </a:solidFill>
+                <a:latin typeface="Calibri" pitchFamily="34" charset="0"/>
+                <a:ea typeface="Calibri" pitchFamily="34" charset="-122"/>
+                <a:cs typeface="Calibri" pitchFamily="34" charset="-120"/>
+              </a:rPr>
+              <a:t>内部</a:t>
+            </a:r>
+            <a:r>
+              <a:rPr lang="en-US" sz="2400" dirty="0" err="1">
+                <a:solidFill>
+                  <a:srgbClr val="FF0000"/>
+                </a:solidFill>
+                <a:latin typeface="Calibri" pitchFamily="34" charset="0"/>
+                <a:ea typeface="Calibri" pitchFamily="34" charset="-122"/>
+                <a:cs typeface="Calibri" pitchFamily="34" charset="-120"/>
+              </a:rPr>
+              <a:t>再bl</a:t>
+            </a:r>
+            <a:r>
+              <a:rPr lang="en-US" sz="2400" dirty="0">
+                <a:solidFill>
+                  <a:srgbClr val="16222E"/>
+                </a:solidFill>
+                <a:latin typeface="Calibri" pitchFamily="34" charset="0"/>
+                <a:ea typeface="Calibri" pitchFamily="34" charset="-122"/>
+                <a:cs typeface="Calibri" pitchFamily="34" charset="-120"/>
+              </a:rPr>
+              <a:t> </a:t>
+            </a:r>
+            <a:r>
+              <a:rPr lang="en-US" sz="2400" dirty="0" err="1">
+                <a:solidFill>
+                  <a:srgbClr val="16222E"/>
+                </a:solidFill>
+                <a:latin typeface="Calibri" pitchFamily="34" charset="0"/>
+                <a:ea typeface="Calibri" pitchFamily="34" charset="-122"/>
+                <a:cs typeface="Calibri" pitchFamily="34" charset="-120"/>
+              </a:rPr>
+              <a:t>别的函数的叫</a:t>
+            </a:r>
+            <a:r>
+              <a:rPr lang="en-US" sz="2400" dirty="0" err="1">
+                <a:solidFill>
+                  <a:srgbClr val="FF0000"/>
+                </a:solidFill>
+                <a:latin typeface="Calibri" pitchFamily="34" charset="0"/>
+                <a:ea typeface="Calibri" pitchFamily="34" charset="-122"/>
+                <a:cs typeface="Calibri" pitchFamily="34" charset="-120"/>
+              </a:rPr>
+              <a:t>非叶子函数</a:t>
+            </a:r>
+            <a:r>
+              <a:rPr lang="zh-CN" altLang="en-US" sz="2400" dirty="0">
+                <a:solidFill>
+                  <a:srgbClr val="FF0000"/>
+                </a:solidFill>
+                <a:latin typeface="Calibri" pitchFamily="34" charset="0"/>
+                <a:ea typeface="Calibri" pitchFamily="34" charset="-122"/>
+                <a:cs typeface="Calibri" pitchFamily="34" charset="-120"/>
+              </a:rPr>
+              <a:t>：</a:t>
+            </a:r>
+            <a:r>
+              <a:rPr lang="en-US" sz="2400" dirty="0">
+                <a:solidFill>
+                  <a:srgbClr val="16222E"/>
+                </a:solidFill>
+                <a:latin typeface="Calibri" pitchFamily="34" charset="0"/>
+                <a:ea typeface="Calibri" pitchFamily="34" charset="-122"/>
+                <a:cs typeface="Calibri" pitchFamily="34" charset="-120"/>
+              </a:rPr>
+              <a:t>bl </a:t>
+            </a:r>
+            <a:r>
+              <a:rPr lang="en-US" sz="2400" dirty="0">
+                <a:solidFill>
+                  <a:srgbClr val="FF0000"/>
+                </a:solidFill>
+                <a:latin typeface="Calibri" pitchFamily="34" charset="0"/>
+                <a:ea typeface="Calibri" pitchFamily="34" charset="-122"/>
+                <a:cs typeface="Calibri" pitchFamily="34" charset="-120"/>
+              </a:rPr>
+              <a:t>会覆盖 ra</a:t>
+            </a:r>
+            <a:r>
+              <a:rPr lang="en-US" sz="2400" dirty="0">
+                <a:solidFill>
+                  <a:srgbClr val="16222E"/>
+                </a:solidFill>
+                <a:latin typeface="Calibri" pitchFamily="34" charset="0"/>
+                <a:ea typeface="Calibri" pitchFamily="34" charset="-122"/>
+                <a:cs typeface="Calibri" pitchFamily="34" charset="-120"/>
+              </a:rPr>
+              <a:t>，返回前</a:t>
+            </a:r>
+            <a:r>
+              <a:rPr lang="en-US" sz="2400" dirty="0">
+                <a:solidFill>
+                  <a:srgbClr val="FF0000"/>
+                </a:solidFill>
+                <a:latin typeface="Calibri" pitchFamily="34" charset="0"/>
+                <a:ea typeface="Calibri" pitchFamily="34" charset="-122"/>
+                <a:cs typeface="Calibri" pitchFamily="34" charset="-120"/>
+              </a:rPr>
+              <a:t>必须先存后取</a:t>
+            </a:r>
+            <a:r>
+              <a:rPr lang="en-US" sz="2400" dirty="0">
+                <a:solidFill>
+                  <a:srgbClr val="16222E"/>
+                </a:solidFill>
+                <a:latin typeface="Calibri" pitchFamily="34" charset="0"/>
+                <a:ea typeface="Calibri" pitchFamily="34" charset="-122"/>
+                <a:cs typeface="Calibri" pitchFamily="34" charset="-120"/>
+              </a:rPr>
+              <a:t>，恢复成自己被调用时收到的 ra（正是上一页 inner 的处境）。</a:t>
+            </a:r>
+            <a:endParaRPr lang="en-US" sz="2400" dirty="0"/>
+          </a:p>
+        </p:txBody>
+      </p:sp>
+      <p:sp>
+        <p:nvSpPr>
+          <p:cNvPr id="7" name="Shape 5"/>
+          <p:cNvSpPr/>
+          <p:nvPr/>
+        </p:nvSpPr>
+        <p:spPr>
+          <a:xfrm>
+            <a:off x="457200" y="2560320"/>
+            <a:ext cx="5473560" cy="2606040"/>
+          </a:xfrm>
+          <a:prstGeom prst="roundRect">
+            <a:avLst>
+              <a:gd name="adj" fmla="val 2051"/>
+            </a:avLst>
+          </a:prstGeom>
+          <a:solidFill>
+            <a:srgbClr val="0B1E3B"/>
+          </a:solidFill>
+          <a:ln/>
           <a:effectLst>
-            <a:outerShdw blurRad="50800" dist="12700" dir="5400000" algn="bl" rotWithShape="0">
+            <a:outerShdw blurRad="76200" dist="25400" dir="5400000" algn="bl" rotWithShape="0">
               <a:srgbClr val="000000">
-                <a:alpha val="8000"/>
+                <a:alpha val="25000"/>
               </a:srgbClr>
             </a:outerShdw>
           </a:effectLst>
@@ -30925,14 +31161,14 @@
       </p:sp>
       <p:sp>
         <p:nvSpPr>
-          <p:cNvPr id="6" name="Text 4"/>
-          <p:cNvSpPr/>
-          <p:nvPr/>
-        </p:nvSpPr>
-        <p:spPr>
-          <a:xfrm>
-            <a:off x="731520" y="1828800"/>
-            <a:ext cx="2743200" cy="914400"/>
+          <p:cNvPr id="8" name="Text 6"/>
+          <p:cNvSpPr/>
+          <p:nvPr/>
+        </p:nvSpPr>
+        <p:spPr>
+          <a:xfrm>
+            <a:off x="487680" y="2706624"/>
+            <a:ext cx="5487048" cy="411480"/>
           </a:xfrm>
           <a:prstGeom prst="rect">
             <a:avLst/>
@@ -30944,158 +31180,251 @@
           <a:bodyPr wrap="square" rtlCol="0" anchor="ctr"/>
           <a:lstStyle/>
           <a:p>
-            <a:pPr marL="0" marR="0" lvl="0" indent="0" algn="l" defTabSz="914400" rtl="0" eaLnBrk="1" fontAlgn="auto" latinLnBrk="0" hangingPunct="1">
-              <a:lnSpc>
-                <a:spcPct val="100000"/>
-              </a:lnSpc>
-              <a:spcBef>
-                <a:spcPts val="0"/>
-              </a:spcBef>
-              <a:spcAft>
-                <a:spcPts val="0"/>
-              </a:spcAft>
-              <a:buClrTx/>
-              <a:buSzTx/>
-              <a:buFontTx/>
-              <a:buNone/>
-              <a:tabLst/>
-              <a:defRPr/>
-            </a:pPr>
-            <a:r>
-              <a:rPr kumimoji="0" lang="en-US" sz="2600" b="1" i="0" u="none" strike="noStrike" kern="1200" cap="none" spc="0" normalizeH="0" baseline="0" noProof="0" dirty="0">
-                <a:ln>
-                  <a:noFill/>
-                </a:ln>
-                <a:solidFill>
-                  <a:srgbClr val="0A4A6E"/>
-                </a:solidFill>
-                <a:effectLst/>
-                <a:uLnTx/>
-                <a:uFillTx/>
-                <a:latin typeface="Courier New" pitchFamily="34" charset="0"/>
-                <a:ea typeface="Courier New" pitchFamily="34" charset="-122"/>
-                <a:cs typeface="Courier New" pitchFamily="34" charset="-120"/>
-              </a:rPr>
-              <a:t>a7</a:t>
-            </a:r>
-            <a:endParaRPr kumimoji="0" lang="en-US" sz="2600" b="0" i="0" u="none" strike="noStrike" kern="1200" cap="none" spc="0" normalizeH="0" baseline="0" noProof="0" dirty="0">
-              <a:ln>
-                <a:noFill/>
-              </a:ln>
-              <a:solidFill>
-                <a:prstClr val="black"/>
-              </a:solidFill>
-              <a:effectLst/>
-              <a:uLnTx/>
-              <a:uFillTx/>
-              <a:latin typeface="Calibri" panose="020F0502020204030204"/>
-              <a:ea typeface="+mn-ea"/>
-              <a:cs typeface="+mn-cs"/>
-            </a:endParaRPr>
-          </a:p>
-        </p:txBody>
-      </p:sp>
-      <p:sp>
-        <p:nvSpPr>
-          <p:cNvPr id="7" name="Text 5"/>
-          <p:cNvSpPr/>
-          <p:nvPr/>
-        </p:nvSpPr>
-        <p:spPr>
-          <a:xfrm>
-            <a:off x="3657600" y="1828800"/>
-            <a:ext cx="7772400" cy="914400"/>
-          </a:xfrm>
-          <a:prstGeom prst="rect">
-            <a:avLst/>
-          </a:prstGeom>
-          <a:noFill/>
-          <a:ln/>
-        </p:spPr>
-        <p:txBody>
-          <a:bodyPr wrap="square" rtlCol="0" anchor="ctr"/>
-          <a:lstStyle/>
-          <a:p>
-            <a:pPr marL="0" marR="0" lvl="0" indent="0" algn="l" defTabSz="914400" rtl="0" eaLnBrk="1" fontAlgn="auto" latinLnBrk="0" hangingPunct="1">
-              <a:lnSpc>
-                <a:spcPct val="100000"/>
-              </a:lnSpc>
-              <a:spcBef>
-                <a:spcPts val="0"/>
-              </a:spcBef>
-              <a:spcAft>
-                <a:spcPts val="0"/>
-              </a:spcAft>
-              <a:buClrTx/>
-              <a:buSzTx/>
-              <a:buFontTx/>
-              <a:buNone/>
-              <a:tabLst/>
-              <a:defRPr/>
-            </a:pPr>
-            <a:r>
-              <a:rPr kumimoji="0" lang="en-US" sz="2400" b="0" i="0" u="none" strike="noStrike" kern="1200" cap="none" spc="0" normalizeH="0" baseline="0" noProof="0" dirty="0">
-                <a:ln>
-                  <a:noFill/>
-                </a:ln>
-                <a:solidFill>
-                  <a:srgbClr val="16222E"/>
-                </a:solidFill>
-                <a:effectLst/>
-                <a:uLnTx/>
-                <a:uFillTx/>
+            <a:pPr marL="0" indent="0" algn="l">
+              <a:buNone/>
+            </a:pPr>
+            <a:r>
+              <a:rPr lang="en-US" sz="2400" b="1" dirty="0">
+                <a:solidFill>
+                  <a:srgbClr val="F2A541"/>
+                </a:solidFill>
                 <a:latin typeface="Calibri" pitchFamily="34" charset="0"/>
                 <a:ea typeface="Calibri" pitchFamily="34" charset="-122"/>
                 <a:cs typeface="Calibri" pitchFamily="34" charset="-120"/>
               </a:rPr>
-              <a:t>系统调用号</a:t>
-            </a:r>
-            <a:endParaRPr kumimoji="0" lang="en-US" sz="2400" b="0" i="0" u="none" strike="noStrike" kern="1200" cap="none" spc="0" normalizeH="0" baseline="0" noProof="0" dirty="0">
-              <a:ln>
-                <a:noFill/>
-              </a:ln>
+              <a:t>叶子函数示例：add_one（内部无 bl）</a:t>
+            </a:r>
+            <a:endParaRPr lang="en-US" sz="2400" dirty="0"/>
+          </a:p>
+        </p:txBody>
+      </p:sp>
+      <p:sp>
+        <p:nvSpPr>
+          <p:cNvPr id="9" name="Text 7"/>
+          <p:cNvSpPr/>
+          <p:nvPr/>
+        </p:nvSpPr>
+        <p:spPr>
+          <a:xfrm>
+            <a:off x="713232" y="3163824"/>
+            <a:ext cx="4961496" cy="2834640"/>
+          </a:xfrm>
+          <a:prstGeom prst="rect">
+            <a:avLst/>
+          </a:prstGeom>
+          <a:noFill/>
+          <a:ln/>
+        </p:spPr>
+        <p:txBody>
+          <a:bodyPr wrap="square" lIns="0" tIns="0" rIns="0" bIns="0" rtlCol="0" anchor="t"/>
+          <a:lstStyle/>
+          <a:p>
+            <a:pPr marL="0" indent="0" algn="l">
+              <a:lnSpc>
+                <a:spcPct val="122000"/>
+              </a:lnSpc>
+              <a:buNone/>
+            </a:pPr>
+            <a:r>
+              <a:rPr sz="2400" dirty="0" err="1">
+                <a:solidFill>
+                  <a:schemeClr val="bg1"/>
+                </a:solidFill>
+                <a:latin typeface="Courier New"/>
+              </a:rPr>
+              <a:t>add_one</a:t>
+            </a:r>
+            <a:r>
+              <a:rPr sz="2400" dirty="0">
+                <a:solidFill>
+                  <a:schemeClr val="bg1"/>
+                </a:solidFill>
+                <a:latin typeface="Courier New"/>
+              </a:rPr>
+              <a:t>:</a:t>
+            </a:r>
+            <a:endParaRPr lang="en-US" sz="2400" dirty="0">
               <a:solidFill>
-                <a:prstClr val="black"/>
+                <a:schemeClr val="bg1"/>
               </a:solidFill>
-              <a:effectLst/>
-              <a:uLnTx/>
-              <a:uFillTx/>
-              <a:latin typeface="Calibri" panose="020F0502020204030204"/>
-              <a:ea typeface="+mn-ea"/>
-              <a:cs typeface="+mn-cs"/>
             </a:endParaRPr>
           </a:p>
-        </p:txBody>
-      </p:sp>
-      <p:sp>
-        <p:nvSpPr>
-          <p:cNvPr id="8" name="Shape 6"/>
-          <p:cNvSpPr/>
-          <p:nvPr/>
-        </p:nvSpPr>
-        <p:spPr>
-          <a:xfrm>
-            <a:off x="457200" y="2880360"/>
-            <a:ext cx="11247120" cy="914400"/>
+          <a:p>
+            <a:pPr>
+              <a:lnSpc>
+                <a:spcPct val="122000"/>
+              </a:lnSpc>
+            </a:pPr>
+            <a:r>
+              <a:rPr sz="2400" dirty="0">
+                <a:solidFill>
+                  <a:schemeClr val="bg1"/>
+                </a:solidFill>
+                <a:latin typeface="Courier New"/>
+              </a:rPr>
+              <a:t>    </a:t>
+            </a:r>
+            <a:r>
+              <a:rPr sz="2400" dirty="0" err="1">
+                <a:solidFill>
+                  <a:schemeClr val="bg1"/>
+                </a:solidFill>
+                <a:latin typeface="Courier New"/>
+              </a:rPr>
+              <a:t>addi.d</a:t>
+            </a:r>
+            <a:r>
+              <a:rPr sz="2400" dirty="0">
+                <a:solidFill>
+                  <a:schemeClr val="bg1"/>
+                </a:solidFill>
+                <a:latin typeface="Courier New"/>
+              </a:rPr>
+              <a:t>  $a0, $a0, 1</a:t>
+            </a:r>
+          </a:p>
+          <a:p>
+            <a:pPr>
+              <a:lnSpc>
+                <a:spcPct val="122000"/>
+              </a:lnSpc>
+            </a:pPr>
+            <a:r>
+              <a:rPr sz="2400" dirty="0">
+                <a:solidFill>
+                  <a:schemeClr val="bg1"/>
+                </a:solidFill>
+                <a:latin typeface="Courier New"/>
+              </a:rPr>
+              <a:t>    </a:t>
+            </a:r>
+            <a:r>
+              <a:rPr sz="2400" dirty="0" err="1">
+                <a:solidFill>
+                  <a:schemeClr val="bg1"/>
+                </a:solidFill>
+                <a:latin typeface="Courier New"/>
+              </a:rPr>
+              <a:t>jr</a:t>
+            </a:r>
+            <a:r>
+              <a:rPr sz="2400" dirty="0">
+                <a:solidFill>
+                  <a:schemeClr val="bg1"/>
+                </a:solidFill>
+                <a:latin typeface="Courier New"/>
+              </a:rPr>
+              <a:t>      $</a:t>
+            </a:r>
+            <a:r>
+              <a:rPr sz="2400" dirty="0" err="1">
+                <a:solidFill>
+                  <a:schemeClr val="bg1"/>
+                </a:solidFill>
+                <a:latin typeface="Courier New"/>
+              </a:rPr>
+              <a:t>ra</a:t>
+            </a:r>
+            <a:endParaRPr sz="2400" dirty="0">
+              <a:solidFill>
+                <a:schemeClr val="bg1"/>
+              </a:solidFill>
+              <a:latin typeface="Courier New"/>
+            </a:endParaRPr>
+          </a:p>
+          <a:p>
+            <a:pPr>
+              <a:lnSpc>
+                <a:spcPct val="122000"/>
+              </a:lnSpc>
+            </a:pPr>
+            <a:r>
+              <a:rPr sz="2400" dirty="0">
+                <a:solidFill>
+                  <a:schemeClr val="bg1"/>
+                </a:solidFill>
+                <a:latin typeface="Courier New"/>
+              </a:rPr>
+              <a:t>    # </a:t>
+            </a:r>
+            <a:r>
+              <a:rPr sz="2400" dirty="0" err="1">
+                <a:solidFill>
+                  <a:schemeClr val="bg1"/>
+                </a:solidFill>
+                <a:latin typeface="Courier New"/>
+              </a:rPr>
+              <a:t>全程无</a:t>
+            </a:r>
+            <a:r>
+              <a:rPr sz="2400" dirty="0">
+                <a:solidFill>
+                  <a:schemeClr val="bg1"/>
+                </a:solidFill>
+                <a:latin typeface="Courier New"/>
+              </a:rPr>
+              <a:t> </a:t>
+            </a:r>
+            <a:r>
+              <a:rPr sz="2400" dirty="0" err="1">
+                <a:solidFill>
+                  <a:schemeClr val="bg1"/>
+                </a:solidFill>
+                <a:latin typeface="Courier New"/>
+              </a:rPr>
+              <a:t>bl，ra</a:t>
+            </a:r>
+            <a:r>
+              <a:rPr sz="2400" dirty="0">
+                <a:solidFill>
+                  <a:schemeClr val="bg1"/>
+                </a:solidFill>
+                <a:latin typeface="Courier New"/>
+              </a:rPr>
+              <a:t> </a:t>
+            </a:r>
+            <a:r>
+              <a:rPr sz="2400" dirty="0" err="1">
+                <a:solidFill>
+                  <a:schemeClr val="bg1"/>
+                </a:solidFill>
+                <a:latin typeface="Courier New"/>
+              </a:rPr>
+              <a:t>不会被覆盖</a:t>
+            </a:r>
+            <a:endParaRPr sz="2400" dirty="0">
+              <a:solidFill>
+                <a:schemeClr val="bg1"/>
+              </a:solidFill>
+              <a:latin typeface="Courier New"/>
+            </a:endParaRPr>
+          </a:p>
+        </p:txBody>
+      </p:sp>
+      <p:sp>
+        <p:nvSpPr>
+          <p:cNvPr id="11" name="Shape 5"/>
+          <p:cNvSpPr/>
+          <p:nvPr/>
+        </p:nvSpPr>
+        <p:spPr>
+          <a:xfrm>
+            <a:off x="5974728" y="2560320"/>
+            <a:ext cx="6217272" cy="4297680"/>
           </a:xfrm>
           <a:prstGeom prst="roundRect">
             <a:avLst>
-              <a:gd name="adj" fmla="val 9000"/>
+              <a:gd name="adj" fmla="val 2051"/>
             </a:avLst>
           </a:prstGeom>
           <a:solidFill>
-            <a:srgbClr val="FFFFFF"/>
+            <a:srgbClr val="0B1E3B"/>
           </a:solidFill>
-          <a:ln w="12700">
-            <a:solidFill>
-              <a:srgbClr val="E1E9EF"/>
-            </a:solidFill>
-            <a:prstDash val="solid"/>
-          </a:ln>
+          <a:ln/>
           <a:effectLst>
-            <a:outerShdw blurRad="50800" dist="12700" dir="5400000" algn="bl" rotWithShape="0">
+            <a:outerShdw blurRad="76200" dist="25400" dir="5400000" algn="bl" rotWithShape="0">
               <a:srgbClr val="000000">
-                <a:alpha val="8000"/>
+                <a:alpha val="25000"/>
               </a:srgbClr>
             </a:outerShdw>
           </a:effectLst>
@@ -31103,14 +31432,14 @@
       </p:sp>
       <p:sp>
         <p:nvSpPr>
-          <p:cNvPr id="9" name="Text 7"/>
-          <p:cNvSpPr/>
-          <p:nvPr/>
-        </p:nvSpPr>
-        <p:spPr>
-          <a:xfrm>
-            <a:off x="731520" y="2880360"/>
-            <a:ext cx="2743200" cy="914400"/>
+          <p:cNvPr id="12" name="Text 6"/>
+          <p:cNvSpPr/>
+          <p:nvPr/>
+        </p:nvSpPr>
+        <p:spPr>
+          <a:xfrm>
+            <a:off x="6274728" y="2706624"/>
+            <a:ext cx="5817528" cy="411480"/>
           </a:xfrm>
           <a:prstGeom prst="rect">
             <a:avLst/>
@@ -31122,474 +31451,469 @@
           <a:bodyPr wrap="square" rtlCol="0" anchor="ctr"/>
           <a:lstStyle/>
           <a:p>
-            <a:pPr marL="0" marR="0" lvl="0" indent="0" algn="l" defTabSz="914400" rtl="0" eaLnBrk="1" fontAlgn="auto" latinLnBrk="0" hangingPunct="1">
-              <a:lnSpc>
-                <a:spcPct val="100000"/>
-              </a:lnSpc>
-              <a:spcBef>
-                <a:spcPts val="0"/>
-              </a:spcBef>
-              <a:spcAft>
-                <a:spcPts val="0"/>
-              </a:spcAft>
-              <a:buClrTx/>
-              <a:buSzTx/>
-              <a:buFontTx/>
-              <a:buNone/>
-              <a:tabLst/>
-              <a:defRPr/>
-            </a:pPr>
-            <a:r>
-              <a:rPr kumimoji="0" lang="en-US" sz="2600" b="1" i="0" u="none" strike="noStrike" kern="1200" cap="none" spc="0" normalizeH="0" baseline="0" noProof="0" dirty="0">
-                <a:ln>
-                  <a:noFill/>
-                </a:ln>
-                <a:solidFill>
-                  <a:srgbClr val="0A4A6E"/>
-                </a:solidFill>
-                <a:effectLst/>
-                <a:uLnTx/>
-                <a:uFillTx/>
-                <a:latin typeface="Courier New" pitchFamily="34" charset="0"/>
-                <a:ea typeface="Courier New" pitchFamily="34" charset="-122"/>
-                <a:cs typeface="Courier New" pitchFamily="34" charset="-120"/>
-              </a:rPr>
-              <a:t>a0 ~ a6</a:t>
-            </a:r>
-            <a:endParaRPr kumimoji="0" lang="en-US" sz="2600" b="0" i="0" u="none" strike="noStrike" kern="1200" cap="none" spc="0" normalizeH="0" baseline="0" noProof="0" dirty="0">
-              <a:ln>
-                <a:noFill/>
-              </a:ln>
-              <a:solidFill>
-                <a:prstClr val="black"/>
-              </a:solidFill>
-              <a:effectLst/>
-              <a:uLnTx/>
-              <a:uFillTx/>
-              <a:latin typeface="Calibri" panose="020F0502020204030204"/>
-              <a:ea typeface="+mn-ea"/>
-              <a:cs typeface="+mn-cs"/>
-            </a:endParaRPr>
-          </a:p>
-        </p:txBody>
-      </p:sp>
-      <p:sp>
-        <p:nvSpPr>
-          <p:cNvPr id="10" name="Text 8"/>
-          <p:cNvSpPr/>
-          <p:nvPr/>
-        </p:nvSpPr>
-        <p:spPr>
-          <a:xfrm>
-            <a:off x="3657600" y="2880360"/>
-            <a:ext cx="7772400" cy="914400"/>
-          </a:xfrm>
-          <a:prstGeom prst="rect">
-            <a:avLst/>
-          </a:prstGeom>
-          <a:noFill/>
-          <a:ln/>
-        </p:spPr>
-        <p:txBody>
-          <a:bodyPr wrap="square" rtlCol="0" anchor="ctr"/>
-          <a:lstStyle/>
-          <a:p>
-            <a:pPr marL="0" marR="0" lvl="0" indent="0" algn="l" defTabSz="914400" rtl="0" eaLnBrk="1" fontAlgn="auto" latinLnBrk="0" hangingPunct="1">
-              <a:lnSpc>
-                <a:spcPct val="100000"/>
-              </a:lnSpc>
-              <a:spcBef>
-                <a:spcPts val="0"/>
-              </a:spcBef>
-              <a:spcAft>
-                <a:spcPts val="0"/>
-              </a:spcAft>
-              <a:buClrTx/>
-              <a:buSzTx/>
-              <a:buFontTx/>
-              <a:buNone/>
-              <a:tabLst/>
-              <a:defRPr/>
-            </a:pPr>
-            <a:r>
-              <a:rPr kumimoji="0" lang="en-US" sz="2400" b="0" i="0" u="none" strike="noStrike" kern="1200" cap="none" spc="0" normalizeH="0" baseline="0" noProof="0" dirty="0">
-                <a:ln>
-                  <a:noFill/>
-                </a:ln>
-                <a:solidFill>
-                  <a:srgbClr val="16222E"/>
-                </a:solidFill>
-                <a:effectLst/>
-                <a:uLnTx/>
-                <a:uFillTx/>
+            <a:pPr marL="0" indent="0" algn="l">
+              <a:buNone/>
+            </a:pPr>
+            <a:r>
+              <a:rPr lang="en-US" sz="2400" b="1" dirty="0">
+                <a:solidFill>
+                  <a:srgbClr val="F2A541"/>
+                </a:solidFill>
                 <a:latin typeface="Calibri" pitchFamily="34" charset="0"/>
                 <a:ea typeface="Calibri" pitchFamily="34" charset="-122"/>
                 <a:cs typeface="Calibri" pitchFamily="34" charset="-120"/>
               </a:rPr>
-              <a:t>系统调用参数</a:t>
-            </a:r>
-            <a:endParaRPr kumimoji="0" lang="en-US" sz="2400" b="0" i="0" u="none" strike="noStrike" kern="1200" cap="none" spc="0" normalizeH="0" baseline="0" noProof="0" dirty="0">
-              <a:ln>
-                <a:noFill/>
-              </a:ln>
+              <a:t>非叶子函数示例：foo（内部 bl bar，必须保存/恢复 ra）</a:t>
+            </a:r>
+            <a:endParaRPr lang="en-US" sz="2400" dirty="0"/>
+          </a:p>
+        </p:txBody>
+      </p:sp>
+      <p:sp>
+        <p:nvSpPr>
+          <p:cNvPr id="13" name="Text 7"/>
+          <p:cNvSpPr/>
+          <p:nvPr/>
+        </p:nvSpPr>
+        <p:spPr>
+          <a:xfrm>
+            <a:off x="6186792" y="3163824"/>
+            <a:ext cx="5817528" cy="2834640"/>
+          </a:xfrm>
+          <a:prstGeom prst="rect">
+            <a:avLst/>
+          </a:prstGeom>
+          <a:noFill/>
+          <a:ln/>
+        </p:spPr>
+        <p:txBody>
+          <a:bodyPr wrap="square" lIns="0" tIns="0" rIns="0" bIns="0" rtlCol="0" anchor="t"/>
+          <a:lstStyle/>
+          <a:p>
+            <a:pPr marL="0" indent="0" algn="l">
+              <a:lnSpc>
+                <a:spcPct val="122000"/>
+              </a:lnSpc>
+              <a:buNone/>
+            </a:pPr>
+            <a:r>
+              <a:rPr sz="2400" dirty="0">
+                <a:solidFill>
+                  <a:schemeClr val="bg1"/>
+                </a:solidFill>
+                <a:latin typeface="Courier New"/>
+              </a:rPr>
+              <a:t>foo:</a:t>
+            </a:r>
+            <a:endParaRPr lang="en-US" sz="2400" dirty="0">
               <a:solidFill>
-                <a:prstClr val="black"/>
+                <a:schemeClr val="bg1"/>
               </a:solidFill>
-              <a:effectLst/>
-              <a:uLnTx/>
-              <a:uFillTx/>
-              <a:latin typeface="Calibri" panose="020F0502020204030204"/>
-              <a:ea typeface="+mn-ea"/>
-              <a:cs typeface="+mn-cs"/>
             </a:endParaRPr>
           </a:p>
-        </p:txBody>
-      </p:sp>
-      <p:sp>
-        <p:nvSpPr>
-          <p:cNvPr id="11" name="Shape 9"/>
-          <p:cNvSpPr/>
-          <p:nvPr/>
-        </p:nvSpPr>
-        <p:spPr>
-          <a:xfrm>
-            <a:off x="457200" y="3931920"/>
-            <a:ext cx="11247120" cy="914400"/>
-          </a:xfrm>
-          <a:prstGeom prst="roundRect">
-            <a:avLst>
-              <a:gd name="adj" fmla="val 9000"/>
-            </a:avLst>
-          </a:prstGeom>
-          <a:solidFill>
-            <a:srgbClr val="FFFFFF"/>
-          </a:solidFill>
-          <a:ln w="12700">
-            <a:solidFill>
-              <a:srgbClr val="E1E9EF"/>
-            </a:solidFill>
-            <a:prstDash val="solid"/>
-          </a:ln>
-          <a:effectLst>
-            <a:outerShdw blurRad="50800" dist="12700" dir="5400000" algn="bl" rotWithShape="0">
-              <a:srgbClr val="000000">
-                <a:alpha val="8000"/>
-              </a:srgbClr>
-            </a:outerShdw>
-          </a:effectLst>
-        </p:spPr>
-      </p:sp>
-      <p:sp>
-        <p:nvSpPr>
-          <p:cNvPr id="12" name="Text 10"/>
-          <p:cNvSpPr/>
-          <p:nvPr/>
-        </p:nvSpPr>
-        <p:spPr>
-          <a:xfrm>
-            <a:off x="731520" y="3931920"/>
-            <a:ext cx="2743200" cy="914400"/>
-          </a:xfrm>
-          <a:prstGeom prst="rect">
-            <a:avLst/>
-          </a:prstGeom>
-          <a:noFill/>
-          <a:ln/>
-        </p:spPr>
-        <p:txBody>
-          <a:bodyPr wrap="square" rtlCol="0" anchor="ctr"/>
-          <a:lstStyle/>
-          <a:p>
-            <a:pPr marL="0" marR="0" lvl="0" indent="0" algn="l" defTabSz="914400" rtl="0" eaLnBrk="1" fontAlgn="auto" latinLnBrk="0" hangingPunct="1">
+          <a:p>
+            <a:pPr>
               <a:lnSpc>
-                <a:spcPct val="100000"/>
+                <a:spcPct val="122000"/>
               </a:lnSpc>
-              <a:spcBef>
-                <a:spcPts val="0"/>
-              </a:spcBef>
-              <a:spcAft>
-                <a:spcPts val="0"/>
-              </a:spcAft>
-              <a:buClrTx/>
-              <a:buSzTx/>
-              <a:buFontTx/>
-              <a:buNone/>
-              <a:tabLst/>
-              <a:defRPr/>
-            </a:pPr>
-            <a:r>
-              <a:rPr kumimoji="0" lang="en-US" sz="2600" b="1" i="0" u="none" strike="noStrike" kern="1200" cap="none" spc="0" normalizeH="0" baseline="0" noProof="0" dirty="0">
-                <a:ln>
-                  <a:noFill/>
-                </a:ln>
-                <a:solidFill>
-                  <a:srgbClr val="0A4A6E"/>
-                </a:solidFill>
-                <a:effectLst/>
-                <a:uLnTx/>
-                <a:uFillTx/>
-                <a:latin typeface="Courier New" pitchFamily="34" charset="0"/>
-                <a:ea typeface="Courier New" pitchFamily="34" charset="-122"/>
-                <a:cs typeface="Courier New" pitchFamily="34" charset="-120"/>
-              </a:rPr>
-              <a:t>a0</a:t>
-            </a:r>
-            <a:endParaRPr kumimoji="0" lang="en-US" sz="2600" b="0" i="0" u="none" strike="noStrike" kern="1200" cap="none" spc="0" normalizeH="0" baseline="0" noProof="0" dirty="0">
-              <a:ln>
-                <a:noFill/>
-              </a:ln>
+            </a:pPr>
+            <a:r>
+              <a:rPr sz="2400" dirty="0">
+                <a:solidFill>
+                  <a:schemeClr val="bg1"/>
+                </a:solidFill>
+                <a:latin typeface="Courier New"/>
+              </a:rPr>
+              <a:t>    </a:t>
+            </a:r>
+            <a:r>
+              <a:rPr sz="2400" dirty="0" err="1">
+                <a:solidFill>
+                  <a:schemeClr val="bg1"/>
+                </a:solidFill>
+                <a:latin typeface="Courier New"/>
+              </a:rPr>
+              <a:t>addi.d</a:t>
+            </a:r>
+            <a:r>
+              <a:rPr sz="2400" dirty="0">
+                <a:solidFill>
+                  <a:schemeClr val="bg1"/>
+                </a:solidFill>
+                <a:latin typeface="Courier New"/>
+              </a:rPr>
+              <a:t>  $</a:t>
+            </a:r>
+            <a:r>
+              <a:rPr sz="2400" dirty="0" err="1">
+                <a:solidFill>
+                  <a:schemeClr val="bg1"/>
+                </a:solidFill>
+                <a:latin typeface="Courier New"/>
+              </a:rPr>
+              <a:t>sp</a:t>
+            </a:r>
+            <a:r>
+              <a:rPr sz="2400" dirty="0">
+                <a:solidFill>
+                  <a:schemeClr val="bg1"/>
+                </a:solidFill>
+                <a:latin typeface="Courier New"/>
+              </a:rPr>
+              <a:t>, $</a:t>
+            </a:r>
+            <a:r>
+              <a:rPr sz="2400" dirty="0" err="1">
+                <a:solidFill>
+                  <a:schemeClr val="bg1"/>
+                </a:solidFill>
+                <a:latin typeface="Courier New"/>
+              </a:rPr>
+              <a:t>sp</a:t>
+            </a:r>
+            <a:r>
+              <a:rPr sz="2400" dirty="0">
+                <a:solidFill>
+                  <a:schemeClr val="bg1"/>
+                </a:solidFill>
+                <a:latin typeface="Courier New"/>
+              </a:rPr>
+              <a:t>, -16</a:t>
+            </a:r>
+          </a:p>
+          <a:p>
+            <a:pPr>
+              <a:lnSpc>
+                <a:spcPct val="122000"/>
+              </a:lnSpc>
+            </a:pPr>
+            <a:r>
+              <a:rPr sz="2400" dirty="0">
+                <a:solidFill>
+                  <a:schemeClr val="bg1"/>
+                </a:solidFill>
+                <a:latin typeface="Courier New"/>
+              </a:rPr>
+              <a:t>    </a:t>
+            </a:r>
+            <a:r>
+              <a:rPr sz="2400" dirty="0" err="1">
+                <a:solidFill>
+                  <a:schemeClr val="bg1"/>
+                </a:solidFill>
+                <a:latin typeface="Courier New"/>
+              </a:rPr>
+              <a:t>st.d</a:t>
+            </a:r>
+            <a:r>
+              <a:rPr sz="2400" dirty="0">
+                <a:solidFill>
+                  <a:schemeClr val="bg1"/>
+                </a:solidFill>
+                <a:latin typeface="Courier New"/>
+              </a:rPr>
+              <a:t>    $</a:t>
+            </a:r>
+            <a:r>
+              <a:rPr sz="2400" dirty="0" err="1">
+                <a:solidFill>
+                  <a:schemeClr val="bg1"/>
+                </a:solidFill>
+                <a:latin typeface="Courier New"/>
+              </a:rPr>
+              <a:t>ra</a:t>
+            </a:r>
+            <a:r>
+              <a:rPr sz="2400" dirty="0">
+                <a:solidFill>
+                  <a:schemeClr val="bg1"/>
+                </a:solidFill>
+                <a:latin typeface="Courier New"/>
+              </a:rPr>
+              <a:t>, $</a:t>
+            </a:r>
+            <a:r>
+              <a:rPr sz="2400" dirty="0" err="1">
+                <a:solidFill>
+                  <a:schemeClr val="bg1"/>
+                </a:solidFill>
+                <a:latin typeface="Courier New"/>
+              </a:rPr>
+              <a:t>sp</a:t>
+            </a:r>
+            <a:r>
+              <a:rPr sz="2400" dirty="0">
+                <a:solidFill>
+                  <a:schemeClr val="bg1"/>
+                </a:solidFill>
+                <a:latin typeface="Courier New"/>
+              </a:rPr>
+              <a:t>, 8</a:t>
+            </a:r>
+          </a:p>
+          <a:p>
+            <a:pPr>
+              <a:lnSpc>
+                <a:spcPct val="122000"/>
+              </a:lnSpc>
+            </a:pPr>
+            <a:r>
+              <a:rPr sz="2400" dirty="0">
+                <a:solidFill>
+                  <a:schemeClr val="bg1"/>
+                </a:solidFill>
+                <a:latin typeface="Courier New"/>
+              </a:rPr>
+              <a:t>    </a:t>
+            </a:r>
+            <a:r>
+              <a:rPr sz="2400" dirty="0">
+                <a:solidFill>
+                  <a:srgbClr val="FF0000"/>
+                </a:solidFill>
+                <a:latin typeface="Courier New"/>
+              </a:rPr>
+              <a:t>bl      bar  </a:t>
+            </a:r>
+            <a:r>
+              <a:rPr sz="2400" dirty="0">
+                <a:solidFill>
+                  <a:schemeClr val="bg1"/>
+                </a:solidFill>
+                <a:latin typeface="Courier New"/>
+              </a:rPr>
+              <a:t># 里</a:t>
+            </a:r>
+            <a:r>
+              <a:rPr lang="zh-CN" altLang="en-US" sz="2400" dirty="0">
+                <a:solidFill>
+                  <a:schemeClr val="bg1"/>
+                </a:solidFill>
+                <a:latin typeface="Courier New"/>
+              </a:rPr>
+              <a:t>面</a:t>
+            </a:r>
+            <a:r>
+              <a:rPr sz="2400" dirty="0" err="1">
+                <a:solidFill>
+                  <a:schemeClr val="bg1"/>
+                </a:solidFill>
+                <a:latin typeface="Courier New"/>
+              </a:rPr>
+              <a:t>会改写</a:t>
+            </a:r>
+            <a:r>
+              <a:rPr sz="2400" dirty="0">
+                <a:solidFill>
+                  <a:schemeClr val="bg1"/>
+                </a:solidFill>
+                <a:latin typeface="Courier New"/>
+              </a:rPr>
+              <a:t> $</a:t>
+            </a:r>
+            <a:r>
+              <a:rPr sz="2400" dirty="0" err="1">
+                <a:solidFill>
+                  <a:schemeClr val="bg1"/>
+                </a:solidFill>
+                <a:latin typeface="Courier New"/>
+              </a:rPr>
+              <a:t>ra</a:t>
+            </a:r>
+            <a:endParaRPr sz="2400" dirty="0">
               <a:solidFill>
-                <a:prstClr val="black"/>
+                <a:schemeClr val="bg1"/>
               </a:solidFill>
-              <a:effectLst/>
-              <a:uLnTx/>
-              <a:uFillTx/>
-              <a:latin typeface="Calibri" panose="020F0502020204030204"/>
-              <a:ea typeface="+mn-ea"/>
-              <a:cs typeface="+mn-cs"/>
+              <a:latin typeface="Courier New"/>
             </a:endParaRPr>
           </a:p>
-        </p:txBody>
-      </p:sp>
-      <p:sp>
-        <p:nvSpPr>
-          <p:cNvPr id="13" name="Text 11"/>
-          <p:cNvSpPr/>
-          <p:nvPr/>
-        </p:nvSpPr>
-        <p:spPr>
-          <a:xfrm>
-            <a:off x="3657600" y="3931920"/>
-            <a:ext cx="7772400" cy="914400"/>
-          </a:xfrm>
-          <a:prstGeom prst="rect">
-            <a:avLst/>
-          </a:prstGeom>
-          <a:noFill/>
-          <a:ln/>
-        </p:spPr>
-        <p:txBody>
-          <a:bodyPr wrap="square" rtlCol="0" anchor="ctr"/>
-          <a:lstStyle/>
-          <a:p>
-            <a:pPr marL="0" marR="0" lvl="0" indent="0" algn="l" defTabSz="914400" rtl="0" eaLnBrk="1" fontAlgn="auto" latinLnBrk="0" hangingPunct="1">
+          <a:p>
+            <a:pPr>
               <a:lnSpc>
-                <a:spcPct val="100000"/>
+                <a:spcPct val="122000"/>
               </a:lnSpc>
-              <a:spcBef>
-                <a:spcPts val="0"/>
-              </a:spcBef>
-              <a:spcAft>
-                <a:spcPts val="0"/>
-              </a:spcAft>
-              <a:buClrTx/>
-              <a:buSzTx/>
-              <a:buFontTx/>
-              <a:buNone/>
-              <a:tabLst/>
-              <a:defRPr/>
-            </a:pPr>
-            <a:r>
-              <a:rPr kumimoji="0" lang="en-US" sz="2400" b="0" i="0" u="none" strike="noStrike" kern="1200" cap="none" spc="0" normalizeH="0" baseline="0" noProof="0" dirty="0">
-                <a:ln>
-                  <a:noFill/>
-                </a:ln>
-                <a:solidFill>
-                  <a:srgbClr val="16222E"/>
-                </a:solidFill>
-                <a:effectLst/>
-                <a:uLnTx/>
-                <a:uFillTx/>
-                <a:latin typeface="Calibri" pitchFamily="34" charset="0"/>
-                <a:ea typeface="Calibri" pitchFamily="34" charset="-122"/>
-                <a:cs typeface="Calibri" pitchFamily="34" charset="-120"/>
-              </a:rPr>
-              <a:t>同时也是返回值（调用后 a0~a6 可能被破坏）</a:t>
-            </a:r>
-            <a:endParaRPr kumimoji="0" lang="en-US" sz="2400" b="0" i="0" u="none" strike="noStrike" kern="1200" cap="none" spc="0" normalizeH="0" baseline="0" noProof="0" dirty="0">
-              <a:ln>
-                <a:noFill/>
-              </a:ln>
+            </a:pPr>
+            <a:r>
+              <a:rPr sz="2400" dirty="0">
+                <a:solidFill>
+                  <a:schemeClr val="bg1"/>
+                </a:solidFill>
+                <a:latin typeface="Courier New"/>
+              </a:rPr>
+              <a:t>    </a:t>
+            </a:r>
+            <a:r>
+              <a:rPr sz="2400" dirty="0" err="1">
+                <a:solidFill>
+                  <a:schemeClr val="bg1"/>
+                </a:solidFill>
+                <a:latin typeface="Courier New"/>
+              </a:rPr>
+              <a:t>ld.d</a:t>
+            </a:r>
+            <a:r>
+              <a:rPr sz="2400" dirty="0">
+                <a:solidFill>
+                  <a:schemeClr val="bg1"/>
+                </a:solidFill>
+                <a:latin typeface="Courier New"/>
+              </a:rPr>
+              <a:t>    $</a:t>
+            </a:r>
+            <a:r>
+              <a:rPr sz="2400" dirty="0" err="1">
+                <a:solidFill>
+                  <a:schemeClr val="bg1"/>
+                </a:solidFill>
+                <a:latin typeface="Courier New"/>
+              </a:rPr>
+              <a:t>ra</a:t>
+            </a:r>
+            <a:r>
+              <a:rPr sz="2400" dirty="0">
+                <a:solidFill>
+                  <a:schemeClr val="bg1"/>
+                </a:solidFill>
+                <a:latin typeface="Courier New"/>
+              </a:rPr>
+              <a:t>, $</a:t>
+            </a:r>
+            <a:r>
+              <a:rPr sz="2400" dirty="0" err="1">
+                <a:solidFill>
+                  <a:schemeClr val="bg1"/>
+                </a:solidFill>
+                <a:latin typeface="Courier New"/>
+              </a:rPr>
+              <a:t>sp</a:t>
+            </a:r>
+            <a:r>
+              <a:rPr sz="2400" dirty="0">
+                <a:solidFill>
+                  <a:schemeClr val="bg1"/>
+                </a:solidFill>
+                <a:latin typeface="Courier New"/>
+              </a:rPr>
+              <a:t>, 8</a:t>
+            </a:r>
+          </a:p>
+          <a:p>
+            <a:pPr>
+              <a:lnSpc>
+                <a:spcPct val="122000"/>
+              </a:lnSpc>
+            </a:pPr>
+            <a:r>
+              <a:rPr sz="2400" dirty="0">
+                <a:solidFill>
+                  <a:schemeClr val="bg1"/>
+                </a:solidFill>
+                <a:latin typeface="Courier New"/>
+              </a:rPr>
+              <a:t>    </a:t>
+            </a:r>
+            <a:r>
+              <a:rPr sz="2400" dirty="0" err="1">
+                <a:solidFill>
+                  <a:schemeClr val="bg1"/>
+                </a:solidFill>
+                <a:latin typeface="Courier New"/>
+              </a:rPr>
+              <a:t>addi.d</a:t>
+            </a:r>
+            <a:r>
+              <a:rPr sz="2400" dirty="0">
+                <a:solidFill>
+                  <a:schemeClr val="bg1"/>
+                </a:solidFill>
+                <a:latin typeface="Courier New"/>
+              </a:rPr>
+              <a:t>  $</a:t>
+            </a:r>
+            <a:r>
+              <a:rPr sz="2400" dirty="0" err="1">
+                <a:solidFill>
+                  <a:schemeClr val="bg1"/>
+                </a:solidFill>
+                <a:latin typeface="Courier New"/>
+              </a:rPr>
+              <a:t>sp</a:t>
+            </a:r>
+            <a:r>
+              <a:rPr sz="2400" dirty="0">
+                <a:solidFill>
+                  <a:schemeClr val="bg1"/>
+                </a:solidFill>
+                <a:latin typeface="Courier New"/>
+              </a:rPr>
+              <a:t>, $</a:t>
+            </a:r>
+            <a:r>
+              <a:rPr sz="2400" dirty="0" err="1">
+                <a:solidFill>
+                  <a:schemeClr val="bg1"/>
+                </a:solidFill>
+                <a:latin typeface="Courier New"/>
+              </a:rPr>
+              <a:t>sp</a:t>
+            </a:r>
+            <a:r>
+              <a:rPr sz="2400" dirty="0">
+                <a:solidFill>
+                  <a:schemeClr val="bg1"/>
+                </a:solidFill>
+                <a:latin typeface="Courier New"/>
+              </a:rPr>
+              <a:t>, 16</a:t>
+            </a:r>
+          </a:p>
+          <a:p>
+            <a:pPr>
+              <a:lnSpc>
+                <a:spcPct val="122000"/>
+              </a:lnSpc>
+            </a:pPr>
+            <a:r>
+              <a:rPr sz="2400" dirty="0">
+                <a:solidFill>
+                  <a:schemeClr val="bg1"/>
+                </a:solidFill>
+                <a:latin typeface="Courier New"/>
+              </a:rPr>
+              <a:t>    </a:t>
+            </a:r>
+            <a:r>
+              <a:rPr sz="2400" dirty="0" err="1">
+                <a:solidFill>
+                  <a:schemeClr val="bg1"/>
+                </a:solidFill>
+                <a:latin typeface="Courier New"/>
+              </a:rPr>
+              <a:t>jr</a:t>
+            </a:r>
+            <a:r>
+              <a:rPr sz="2400" dirty="0">
+                <a:solidFill>
+                  <a:schemeClr val="bg1"/>
+                </a:solidFill>
+                <a:latin typeface="Courier New"/>
+              </a:rPr>
+              <a:t>      $</a:t>
+            </a:r>
+            <a:r>
+              <a:rPr sz="2400" dirty="0" err="1">
+                <a:solidFill>
+                  <a:schemeClr val="bg1"/>
+                </a:solidFill>
+                <a:latin typeface="Courier New"/>
+              </a:rPr>
+              <a:t>ra</a:t>
+            </a:r>
+            <a:endParaRPr sz="2400" dirty="0">
               <a:solidFill>
-                <a:prstClr val="black"/>
+                <a:schemeClr val="bg1"/>
               </a:solidFill>
-              <a:effectLst/>
-              <a:uLnTx/>
-              <a:uFillTx/>
-              <a:latin typeface="Calibri" panose="020F0502020204030204"/>
-              <a:ea typeface="+mn-ea"/>
-              <a:cs typeface="+mn-cs"/>
-            </a:endParaRPr>
-          </a:p>
-        </p:txBody>
-      </p:sp>
-      <p:sp>
-        <p:nvSpPr>
-          <p:cNvPr id="14" name="Shape 12"/>
-          <p:cNvSpPr/>
-          <p:nvPr/>
-        </p:nvSpPr>
-        <p:spPr>
-          <a:xfrm>
-            <a:off x="457200" y="5074920"/>
-            <a:ext cx="11247120" cy="1051560"/>
-          </a:xfrm>
-          <a:prstGeom prst="roundRect">
-            <a:avLst>
-              <a:gd name="adj" fmla="val 8696"/>
-            </a:avLst>
-          </a:prstGeom>
-          <a:solidFill>
-            <a:srgbClr val="FDF3E4"/>
-          </a:solidFill>
-          <a:ln w="12700">
-            <a:solidFill>
-              <a:srgbClr val="F2A541"/>
-            </a:solidFill>
-            <a:prstDash val="solid"/>
-          </a:ln>
-        </p:spPr>
-      </p:sp>
-      <p:sp>
-        <p:nvSpPr>
-          <p:cNvPr id="15" name="Text 13"/>
-          <p:cNvSpPr/>
-          <p:nvPr/>
-        </p:nvSpPr>
-        <p:spPr>
-          <a:xfrm>
-            <a:off x="685800" y="5074920"/>
-            <a:ext cx="10789920" cy="1051560"/>
-          </a:xfrm>
-          <a:prstGeom prst="rect">
-            <a:avLst/>
-          </a:prstGeom>
-          <a:noFill/>
-          <a:ln/>
-        </p:spPr>
-        <p:txBody>
-          <a:bodyPr wrap="square" rtlCol="0" anchor="ctr"/>
-          <a:lstStyle/>
-          <a:p>
-            <a:pPr marL="0" marR="0" lvl="0" indent="0" algn="l" defTabSz="914400" rtl="0" eaLnBrk="1" fontAlgn="auto" latinLnBrk="0" hangingPunct="1">
-              <a:lnSpc>
-                <a:spcPct val="100000"/>
-              </a:lnSpc>
-              <a:spcBef>
-                <a:spcPts val="0"/>
-              </a:spcBef>
-              <a:spcAft>
-                <a:spcPts val="0"/>
-              </a:spcAft>
-              <a:buClrTx/>
-              <a:buSzTx/>
-              <a:buFontTx/>
-              <a:buNone/>
-              <a:tabLst/>
-              <a:defRPr/>
-            </a:pPr>
-            <a:r>
-              <a:rPr kumimoji="0" lang="en-US" sz="2400" b="0" i="0" u="none" strike="noStrike" kern="1200" cap="none" spc="0" normalizeH="0" baseline="0" noProof="0" dirty="0">
-                <a:ln>
-                  <a:noFill/>
-                </a:ln>
-                <a:solidFill>
-                  <a:srgbClr val="6B5836"/>
-                </a:solidFill>
-                <a:effectLst/>
-                <a:uLnTx/>
-                <a:uFillTx/>
-                <a:latin typeface="Calibri" pitchFamily="34" charset="0"/>
-                <a:ea typeface="Calibri" pitchFamily="34" charset="-122"/>
-                <a:cs typeface="Calibri" pitchFamily="34" charset="-120"/>
-              </a:rPr>
-              <a:t>不同于普通函数调用约定：系统调用回来后，a0~a6 的值可能被破坏，不保证保留。</a:t>
-            </a:r>
-            <a:endParaRPr kumimoji="0" lang="en-US" sz="2400" b="0" i="0" u="none" strike="noStrike" kern="1200" cap="none" spc="0" normalizeH="0" baseline="0" noProof="0" dirty="0">
-              <a:ln>
-                <a:noFill/>
-              </a:ln>
-              <a:solidFill>
-                <a:prstClr val="black"/>
-              </a:solidFill>
-              <a:effectLst/>
-              <a:uLnTx/>
-              <a:uFillTx/>
-              <a:latin typeface="Calibri" panose="020F0502020204030204"/>
-              <a:ea typeface="+mn-ea"/>
-              <a:cs typeface="+mn-cs"/>
-            </a:endParaRPr>
-          </a:p>
-        </p:txBody>
-      </p:sp>
-      <p:sp>
-        <p:nvSpPr>
-          <p:cNvPr id="16" name="Text 14"/>
-          <p:cNvSpPr/>
-          <p:nvPr/>
-        </p:nvSpPr>
-        <p:spPr>
-          <a:xfrm>
-            <a:off x="7132320" y="6355080"/>
-            <a:ext cx="4572000" cy="365760"/>
-          </a:xfrm>
-          <a:prstGeom prst="rect">
-            <a:avLst/>
-          </a:prstGeom>
-          <a:noFill/>
-          <a:ln/>
-        </p:spPr>
-        <p:txBody>
-          <a:bodyPr wrap="square" rtlCol="0" anchor="ctr"/>
-          <a:lstStyle/>
-          <a:p>
-            <a:pPr marL="0" marR="0" lvl="0" indent="0" algn="r" defTabSz="914400" rtl="0" eaLnBrk="1" fontAlgn="auto" latinLnBrk="0" hangingPunct="1">
-              <a:lnSpc>
-                <a:spcPct val="100000"/>
-              </a:lnSpc>
-              <a:spcBef>
-                <a:spcPts val="0"/>
-              </a:spcBef>
-              <a:spcAft>
-                <a:spcPts val="0"/>
-              </a:spcAft>
-              <a:buClrTx/>
-              <a:buSzTx/>
-              <a:buFontTx/>
-              <a:buNone/>
-              <a:tabLst/>
-              <a:defRPr/>
-            </a:pPr>
-            <a:r>
-              <a:rPr kumimoji="0" lang="en-US" sz="2400" b="0" i="0" u="none" strike="noStrike" kern="1200" cap="none" spc="0" normalizeH="0" baseline="0" noProof="0" dirty="0">
-                <a:ln>
-                  <a:noFill/>
-                </a:ln>
-                <a:solidFill>
-                  <a:srgbClr val="9AAABB"/>
-                </a:solidFill>
-                <a:effectLst/>
-                <a:uLnTx/>
-                <a:uFillTx/>
-                <a:latin typeface="Calibri" pitchFamily="34" charset="0"/>
-                <a:ea typeface="Calibri" pitchFamily="34" charset="-122"/>
-                <a:cs typeface="Calibri" pitchFamily="34" charset="-120"/>
-              </a:rPr>
-              <a:t>ABI 介绍 · 下</a:t>
-            </a:r>
-            <a:endParaRPr kumimoji="0" lang="en-US" sz="2400" b="0" i="0" u="none" strike="noStrike" kern="1200" cap="none" spc="0" normalizeH="0" baseline="0" noProof="0" dirty="0">
-              <a:ln>
-                <a:noFill/>
-              </a:ln>
-              <a:solidFill>
-                <a:prstClr val="black"/>
-              </a:solidFill>
-              <a:effectLst/>
-              <a:uLnTx/>
-              <a:uFillTx/>
-              <a:latin typeface="Calibri" panose="020F0502020204030204"/>
-              <a:ea typeface="+mn-ea"/>
-              <a:cs typeface="+mn-cs"/>
+              <a:latin typeface="Courier New"/>
             </a:endParaRPr>
           </a:p>
         </p:txBody>
@@ -32261,7 +32585,7 @@
                 <a:ea typeface="Calibri" pitchFamily="34" charset="-122"/>
                 <a:cs typeface="Calibri" pitchFamily="34" charset="-120"/>
               </a:rPr>
-              <a:t>5.5 · 系统调用例子</a:t>
+              <a:t>5.5 · 系统调用约定</a:t>
             </a:r>
             <a:endParaRPr kumimoji="0" lang="en-US" sz="2400" b="0" i="0" u="none" strike="noStrike" kern="1200" cap="none" spc="0" normalizeH="0" baseline="0" noProof="0" dirty="0">
               <a:ln>
@@ -32333,7 +32657,7 @@
                 <a:ea typeface="Cambria" pitchFamily="34" charset="-122"/>
                 <a:cs typeface="Cambria" pitchFamily="34" charset="-120"/>
               </a:rPr>
-              <a:t>系统调用例子：sys_write 输出字符串</a:t>
+              <a:t>系统调用约定：a7 传号，a0~a6 传参</a:t>
             </a:r>
             <a:endParaRPr kumimoji="0" lang="en-US" sz="2800" b="0" i="0" u="none" strike="noStrike" kern="1200" cap="none" spc="0" normalizeH="0" baseline="0" noProof="0" dirty="0">
               <a:ln>
@@ -32360,18 +32684,30 @@
         </p:nvSpPr>
         <p:spPr>
           <a:xfrm>
-            <a:off x="457200" y="1691640"/>
-            <a:ext cx="11247120" cy="640080"/>
+            <a:off x="457200" y="1828800"/>
+            <a:ext cx="11247120" cy="914400"/>
           </a:xfrm>
           <a:prstGeom prst="roundRect">
             <a:avLst>
-              <a:gd name="adj" fmla="val 14286"/>
+              <a:gd name="adj" fmla="val 9000"/>
             </a:avLst>
           </a:prstGeom>
           <a:solidFill>
-            <a:srgbClr val="EAF3F8"/>
+            <a:srgbClr val="FFFFFF"/>
           </a:solidFill>
-          <a:ln/>
+          <a:ln w="12700">
+            <a:solidFill>
+              <a:srgbClr val="E1E9EF"/>
+            </a:solidFill>
+            <a:prstDash val="solid"/>
+          </a:ln>
+          <a:effectLst>
+            <a:outerShdw blurRad="50800" dist="12700" dir="5400000" algn="bl" rotWithShape="0">
+              <a:srgbClr val="000000">
+                <a:alpha val="8000"/>
+              </a:srgbClr>
+            </a:outerShdw>
+          </a:effectLst>
         </p:spPr>
       </p:sp>
       <p:sp>
@@ -32382,8 +32718,80 @@
         </p:nvSpPr>
         <p:spPr>
           <a:xfrm>
-            <a:off x="731520" y="1691640"/>
-            <a:ext cx="10698480" cy="640080"/>
+            <a:off x="731520" y="1828800"/>
+            <a:ext cx="2743200" cy="914400"/>
+          </a:xfrm>
+          <a:prstGeom prst="rect">
+            <a:avLst/>
+          </a:prstGeom>
+          <a:noFill/>
+          <a:ln/>
+        </p:spPr>
+        <p:txBody>
+          <a:bodyPr wrap="square" rtlCol="0" anchor="ctr"/>
+          <a:lstStyle/>
+          <a:p>
+            <a:pPr marL="0" marR="0" lvl="0" indent="0" algn="l" defTabSz="914400" rtl="0" eaLnBrk="1" fontAlgn="auto" latinLnBrk="0" hangingPunct="1">
+              <a:lnSpc>
+                <a:spcPct val="100000"/>
+              </a:lnSpc>
+              <a:spcBef>
+                <a:spcPts val="0"/>
+              </a:spcBef>
+              <a:spcAft>
+                <a:spcPts val="0"/>
+              </a:spcAft>
+              <a:buClrTx/>
+              <a:buSzTx/>
+              <a:buFontTx/>
+              <a:buNone/>
+              <a:tabLst/>
+              <a:defRPr/>
+            </a:pPr>
+            <a:r>
+              <a:rPr kumimoji="0" lang="en-US" sz="2600" b="1" i="0" u="none" strike="noStrike" kern="1200" cap="none" spc="0" normalizeH="0" baseline="0" noProof="0" dirty="0">
+                <a:ln>
+                  <a:noFill/>
+                </a:ln>
+                <a:solidFill>
+                  <a:srgbClr val="0A4A6E"/>
+                </a:solidFill>
+                <a:effectLst/>
+                <a:uLnTx/>
+                <a:uFillTx/>
+                <a:latin typeface="Courier New" pitchFamily="34" charset="0"/>
+                <a:ea typeface="Courier New" pitchFamily="34" charset="-122"/>
+                <a:cs typeface="Courier New" pitchFamily="34" charset="-120"/>
+              </a:rPr>
+              <a:t>a7</a:t>
+            </a:r>
+            <a:endParaRPr kumimoji="0" lang="en-US" sz="2600" b="0" i="0" u="none" strike="noStrike" kern="1200" cap="none" spc="0" normalizeH="0" baseline="0" noProof="0" dirty="0">
+              <a:ln>
+                <a:noFill/>
+              </a:ln>
+              <a:solidFill>
+                <a:prstClr val="black"/>
+              </a:solidFill>
+              <a:effectLst/>
+              <a:uLnTx/>
+              <a:uFillTx/>
+              <a:latin typeface="Calibri" panose="020F0502020204030204"/>
+              <a:ea typeface="+mn-ea"/>
+              <a:cs typeface="+mn-cs"/>
+            </a:endParaRPr>
+          </a:p>
+        </p:txBody>
+      </p:sp>
+      <p:sp>
+        <p:nvSpPr>
+          <p:cNvPr id="7" name="Text 5"/>
+          <p:cNvSpPr/>
+          <p:nvPr/>
+        </p:nvSpPr>
+        <p:spPr>
+          <a:xfrm>
+            <a:off x="3657600" y="1828800"/>
+            <a:ext cx="7772400" cy="914400"/>
           </a:xfrm>
           <a:prstGeom prst="rect">
             <a:avLst/>
@@ -32427,7 +32835,7 @@
                 <a:ea typeface="Calibri" pitchFamily="34" charset="-122"/>
                 <a:cs typeface="Calibri" pitchFamily="34" charset="-120"/>
               </a:rPr>
-              <a:t>sys_write 系统调用号是 64：fd=1（stdout）、字符串地址、字符串长度。</a:t>
+              <a:t>系统调用号</a:t>
             </a:r>
             <a:endParaRPr kumimoji="0" lang="en-US" sz="2400" b="0" i="0" u="none" strike="noStrike" kern="1200" cap="none" spc="0" normalizeH="0" baseline="0" noProof="0" dirty="0">
               <a:ln>
@@ -32448,28 +32856,33 @@
       </p:sp>
       <p:sp>
         <p:nvSpPr>
-          <p:cNvPr id="7" name="Shape 5"/>
-          <p:cNvSpPr/>
-          <p:nvPr/>
-        </p:nvSpPr>
-        <p:spPr>
-          <a:xfrm>
-            <a:off x="457200" y="2377440"/>
-            <a:ext cx="11247120" cy="3246120"/>
+          <p:cNvPr id="8" name="Shape 6"/>
+          <p:cNvSpPr/>
+          <p:nvPr/>
+        </p:nvSpPr>
+        <p:spPr>
+          <a:xfrm>
+            <a:off x="457200" y="2880360"/>
+            <a:ext cx="11247120" cy="914400"/>
           </a:xfrm>
           <a:prstGeom prst="roundRect">
             <a:avLst>
-              <a:gd name="adj" fmla="val 2254"/>
+              <a:gd name="adj" fmla="val 9000"/>
             </a:avLst>
           </a:prstGeom>
           <a:solidFill>
-            <a:srgbClr val="0B1E3B"/>
+            <a:srgbClr val="FFFFFF"/>
           </a:solidFill>
-          <a:ln/>
+          <a:ln w="12700">
+            <a:solidFill>
+              <a:srgbClr val="E1E9EF"/>
+            </a:solidFill>
+            <a:prstDash val="solid"/>
+          </a:ln>
           <a:effectLst>
-            <a:outerShdw blurRad="76200" dist="25400" dir="5400000" algn="bl" rotWithShape="0">
+            <a:outerShdw blurRad="50800" dist="12700" dir="5400000" algn="bl" rotWithShape="0">
               <a:srgbClr val="000000">
-                <a:alpha val="25000"/>
+                <a:alpha val="8000"/>
               </a:srgbClr>
             </a:outerShdw>
           </a:effectLst>
@@ -32477,14 +32890,14 @@
       </p:sp>
       <p:sp>
         <p:nvSpPr>
-          <p:cNvPr id="8" name="Text 6"/>
-          <p:cNvSpPr/>
-          <p:nvPr/>
-        </p:nvSpPr>
-        <p:spPr>
-          <a:xfrm>
-            <a:off x="713232" y="2523744"/>
-            <a:ext cx="10735056" cy="411480"/>
+          <p:cNvPr id="9" name="Text 7"/>
+          <p:cNvSpPr/>
+          <p:nvPr/>
+        </p:nvSpPr>
+        <p:spPr>
+          <a:xfrm>
+            <a:off x="731520" y="2880360"/>
+            <a:ext cx="2743200" cy="914400"/>
           </a:xfrm>
           <a:prstGeom prst="rect">
             <a:avLst/>
@@ -32514,12 +32927,84 @@
               <a:defRPr/>
             </a:pPr>
             <a:r>
-              <a:rPr kumimoji="0" lang="en-US" sz="2400" b="1" i="0" u="none" strike="noStrike" kern="1200" cap="none" spc="0" normalizeH="0" baseline="0" noProof="0" dirty="0">
+              <a:rPr kumimoji="0" lang="en-US" sz="2600" b="1" i="0" u="none" strike="noStrike" kern="1200" cap="none" spc="0" normalizeH="0" baseline="0" noProof="0" dirty="0">
                 <a:ln>
                   <a:noFill/>
                 </a:ln>
                 <a:solidFill>
-                  <a:srgbClr val="F2A541"/>
+                  <a:srgbClr val="0A4A6E"/>
+                </a:solidFill>
+                <a:effectLst/>
+                <a:uLnTx/>
+                <a:uFillTx/>
+                <a:latin typeface="Courier New" pitchFamily="34" charset="0"/>
+                <a:ea typeface="Courier New" pitchFamily="34" charset="-122"/>
+                <a:cs typeface="Courier New" pitchFamily="34" charset="-120"/>
+              </a:rPr>
+              <a:t>a0 ~ a6</a:t>
+            </a:r>
+            <a:endParaRPr kumimoji="0" lang="en-US" sz="2600" b="0" i="0" u="none" strike="noStrike" kern="1200" cap="none" spc="0" normalizeH="0" baseline="0" noProof="0" dirty="0">
+              <a:ln>
+                <a:noFill/>
+              </a:ln>
+              <a:solidFill>
+                <a:prstClr val="black"/>
+              </a:solidFill>
+              <a:effectLst/>
+              <a:uLnTx/>
+              <a:uFillTx/>
+              <a:latin typeface="Calibri" panose="020F0502020204030204"/>
+              <a:ea typeface="+mn-ea"/>
+              <a:cs typeface="+mn-cs"/>
+            </a:endParaRPr>
+          </a:p>
+        </p:txBody>
+      </p:sp>
+      <p:sp>
+        <p:nvSpPr>
+          <p:cNvPr id="10" name="Text 8"/>
+          <p:cNvSpPr/>
+          <p:nvPr/>
+        </p:nvSpPr>
+        <p:spPr>
+          <a:xfrm>
+            <a:off x="3657600" y="2880360"/>
+            <a:ext cx="7772400" cy="914400"/>
+          </a:xfrm>
+          <a:prstGeom prst="rect">
+            <a:avLst/>
+          </a:prstGeom>
+          <a:noFill/>
+          <a:ln/>
+        </p:spPr>
+        <p:txBody>
+          <a:bodyPr wrap="square" rtlCol="0" anchor="ctr"/>
+          <a:lstStyle/>
+          <a:p>
+            <a:pPr marL="0" marR="0" lvl="0" indent="0" algn="l" defTabSz="914400" rtl="0" eaLnBrk="1" fontAlgn="auto" latinLnBrk="0" hangingPunct="1">
+              <a:lnSpc>
+                <a:spcPct val="100000"/>
+              </a:lnSpc>
+              <a:spcBef>
+                <a:spcPts val="0"/>
+              </a:spcBef>
+              <a:spcAft>
+                <a:spcPts val="0"/>
+              </a:spcAft>
+              <a:buClrTx/>
+              <a:buSzTx/>
+              <a:buFontTx/>
+              <a:buNone/>
+              <a:tabLst/>
+              <a:defRPr/>
+            </a:pPr>
+            <a:r>
+              <a:rPr kumimoji="0" lang="en-US" sz="2400" b="0" i="0" u="none" strike="noStrike" kern="1200" cap="none" spc="0" normalizeH="0" baseline="0" noProof="0" dirty="0">
+                <a:ln>
+                  <a:noFill/>
+                </a:ln>
+                <a:solidFill>
+                  <a:srgbClr val="16222E"/>
                 </a:solidFill>
                 <a:effectLst/>
                 <a:uLnTx/>
@@ -32528,7 +33013,7 @@
                 <a:ea typeface="Calibri" pitchFamily="34" charset="-122"/>
                 <a:cs typeface="Calibri" pitchFamily="34" charset="-120"/>
               </a:rPr>
-              <a:t>syscall_test.S</a:t>
+              <a:t>系统调用参数</a:t>
             </a:r>
             <a:endParaRPr kumimoji="0" lang="en-US" sz="2400" b="0" i="0" u="none" strike="noStrike" kern="1200" cap="none" spc="0" normalizeH="0" baseline="0" noProof="0" dirty="0">
               <a:ln>
@@ -32549,28 +33034,62 @@
       </p:sp>
       <p:sp>
         <p:nvSpPr>
-          <p:cNvPr id="9" name="Text 7"/>
-          <p:cNvSpPr/>
-          <p:nvPr/>
-        </p:nvSpPr>
-        <p:spPr>
-          <a:xfrm>
-            <a:off x="713232" y="2980944"/>
-            <a:ext cx="10735056" cy="2514600"/>
-          </a:xfrm>
-          <a:prstGeom prst="rect">
-            <a:avLst/>
-          </a:prstGeom>
-          <a:noFill/>
-          <a:ln/>
-        </p:spPr>
-        <p:txBody>
-          <a:bodyPr wrap="square" lIns="0" tIns="0" rIns="0" bIns="0" rtlCol="0" anchor="t"/>
+          <p:cNvPr id="11" name="Shape 9"/>
+          <p:cNvSpPr/>
+          <p:nvPr/>
+        </p:nvSpPr>
+        <p:spPr>
+          <a:xfrm>
+            <a:off x="457200" y="3931920"/>
+            <a:ext cx="11247120" cy="914400"/>
+          </a:xfrm>
+          <a:prstGeom prst="roundRect">
+            <a:avLst>
+              <a:gd name="adj" fmla="val 9000"/>
+            </a:avLst>
+          </a:prstGeom>
+          <a:solidFill>
+            <a:srgbClr val="FFFFFF"/>
+          </a:solidFill>
+          <a:ln w="12700">
+            <a:solidFill>
+              <a:srgbClr val="E1E9EF"/>
+            </a:solidFill>
+            <a:prstDash val="solid"/>
+          </a:ln>
+          <a:effectLst>
+            <a:outerShdw blurRad="50800" dist="12700" dir="5400000" algn="bl" rotWithShape="0">
+              <a:srgbClr val="000000">
+                <a:alpha val="8000"/>
+              </a:srgbClr>
+            </a:outerShdw>
+          </a:effectLst>
+        </p:spPr>
+      </p:sp>
+      <p:sp>
+        <p:nvSpPr>
+          <p:cNvPr id="12" name="Text 10"/>
+          <p:cNvSpPr/>
+          <p:nvPr/>
+        </p:nvSpPr>
+        <p:spPr>
+          <a:xfrm>
+            <a:off x="731520" y="3931920"/>
+            <a:ext cx="2743200" cy="914400"/>
+          </a:xfrm>
+          <a:prstGeom prst="rect">
+            <a:avLst/>
+          </a:prstGeom>
+          <a:noFill/>
+          <a:ln/>
+        </p:spPr>
+        <p:txBody>
+          <a:bodyPr wrap="square" rtlCol="0" anchor="ctr"/>
           <a:lstStyle/>
           <a:p>
             <a:pPr marL="0" marR="0" lvl="0" indent="0" algn="l" defTabSz="914400" rtl="0" eaLnBrk="1" fontAlgn="auto" latinLnBrk="0" hangingPunct="1">
               <a:lnSpc>
-                <a:spcPct val="122000"/>
+                <a:spcPct val="100000"/>
               </a:lnSpc>
               <a:spcBef>
                 <a:spcPts val="0"/>
@@ -32586,12 +33105,12 @@
               <a:defRPr/>
             </a:pPr>
             <a:r>
-              <a:rPr kumimoji="0" lang="en-US" sz="2400" b="0" i="0" u="none" strike="noStrike" kern="1200" cap="none" spc="0" normalizeH="0" baseline="0" noProof="0" dirty="0">
+              <a:rPr kumimoji="0" lang="en-US" sz="2600" b="1" i="0" u="none" strike="noStrike" kern="1200" cap="none" spc="0" normalizeH="0" baseline="0" noProof="0" dirty="0">
                 <a:ln>
                   <a:noFill/>
                 </a:ln>
                 <a:solidFill>
-                  <a:srgbClr val="CFE8F3"/>
+                  <a:srgbClr val="0A4A6E"/>
                 </a:solidFill>
                 <a:effectLst/>
                 <a:uLnTx/>
@@ -32600,7 +33119,79 @@
                 <a:ea typeface="Courier New" pitchFamily="34" charset="-122"/>
                 <a:cs typeface="Courier New" pitchFamily="34" charset="-120"/>
               </a:rPr>
-              <a:t>li.d  $a7, 64          # sys_write 调用号</a:t>
+              <a:t>a0</a:t>
+            </a:r>
+            <a:endParaRPr kumimoji="0" lang="en-US" sz="2600" b="0" i="0" u="none" strike="noStrike" kern="1200" cap="none" spc="0" normalizeH="0" baseline="0" noProof="0" dirty="0">
+              <a:ln>
+                <a:noFill/>
+              </a:ln>
+              <a:solidFill>
+                <a:prstClr val="black"/>
+              </a:solidFill>
+              <a:effectLst/>
+              <a:uLnTx/>
+              <a:uFillTx/>
+              <a:latin typeface="Calibri" panose="020F0502020204030204"/>
+              <a:ea typeface="+mn-ea"/>
+              <a:cs typeface="+mn-cs"/>
+            </a:endParaRPr>
+          </a:p>
+        </p:txBody>
+      </p:sp>
+      <p:sp>
+        <p:nvSpPr>
+          <p:cNvPr id="13" name="Text 11"/>
+          <p:cNvSpPr/>
+          <p:nvPr/>
+        </p:nvSpPr>
+        <p:spPr>
+          <a:xfrm>
+            <a:off x="3657600" y="3931920"/>
+            <a:ext cx="7772400" cy="914400"/>
+          </a:xfrm>
+          <a:prstGeom prst="rect">
+            <a:avLst/>
+          </a:prstGeom>
+          <a:noFill/>
+          <a:ln/>
+        </p:spPr>
+        <p:txBody>
+          <a:bodyPr wrap="square" rtlCol="0" anchor="ctr"/>
+          <a:lstStyle/>
+          <a:p>
+            <a:pPr marL="0" marR="0" lvl="0" indent="0" algn="l" defTabSz="914400" rtl="0" eaLnBrk="1" fontAlgn="auto" latinLnBrk="0" hangingPunct="1">
+              <a:lnSpc>
+                <a:spcPct val="100000"/>
+              </a:lnSpc>
+              <a:spcBef>
+                <a:spcPts val="0"/>
+              </a:spcBef>
+              <a:spcAft>
+                <a:spcPts val="0"/>
+              </a:spcAft>
+              <a:buClrTx/>
+              <a:buSzTx/>
+              <a:buFontTx/>
+              <a:buNone/>
+              <a:tabLst/>
+              <a:defRPr/>
+            </a:pPr>
+            <a:r>
+              <a:rPr kumimoji="0" lang="en-US" sz="2400" b="0" i="0" u="none" strike="noStrike" kern="1200" cap="none" spc="0" normalizeH="0" baseline="0" noProof="0" dirty="0">
+                <a:ln>
+                  <a:noFill/>
+                </a:ln>
+                <a:solidFill>
+                  <a:srgbClr val="16222E"/>
+                </a:solidFill>
+                <a:effectLst/>
+                <a:uLnTx/>
+                <a:uFillTx/>
+                <a:latin typeface="Calibri" pitchFamily="34" charset="0"/>
+                <a:ea typeface="Calibri" pitchFamily="34" charset="-122"/>
+                <a:cs typeface="Calibri" pitchFamily="34" charset="-120"/>
+              </a:rPr>
+              <a:t>同时也是返回值（调用后 a0~a6 可能被破坏）</a:t>
             </a:r>
             <a:endParaRPr kumimoji="0" lang="en-US" sz="2400" b="0" i="0" u="none" strike="noStrike" kern="1200" cap="none" spc="0" normalizeH="0" baseline="0" noProof="0" dirty="0">
               <a:ln>
@@ -32617,10 +33208,59 @@
               <a:cs typeface="+mn-cs"/>
             </a:endParaRPr>
           </a:p>
+        </p:txBody>
+      </p:sp>
+      <p:sp>
+        <p:nvSpPr>
+          <p:cNvPr id="14" name="Shape 12"/>
+          <p:cNvSpPr/>
+          <p:nvPr/>
+        </p:nvSpPr>
+        <p:spPr>
+          <a:xfrm>
+            <a:off x="457200" y="5074920"/>
+            <a:ext cx="11247120" cy="1051560"/>
+          </a:xfrm>
+          <a:prstGeom prst="roundRect">
+            <a:avLst>
+              <a:gd name="adj" fmla="val 8696"/>
+            </a:avLst>
+          </a:prstGeom>
+          <a:solidFill>
+            <a:srgbClr val="FDF3E4"/>
+          </a:solidFill>
+          <a:ln w="12700">
+            <a:solidFill>
+              <a:srgbClr val="F2A541"/>
+            </a:solidFill>
+            <a:prstDash val="solid"/>
+          </a:ln>
+        </p:spPr>
+      </p:sp>
+      <p:sp>
+        <p:nvSpPr>
+          <p:cNvPr id="15" name="Text 13"/>
+          <p:cNvSpPr/>
+          <p:nvPr/>
+        </p:nvSpPr>
+        <p:spPr>
+          <a:xfrm>
+            <a:off x="685800" y="5074920"/>
+            <a:ext cx="10789920" cy="1051560"/>
+          </a:xfrm>
+          <a:prstGeom prst="rect">
+            <a:avLst/>
+          </a:prstGeom>
+          <a:noFill/>
+          <a:ln/>
+        </p:spPr>
+        <p:txBody>
+          <a:bodyPr wrap="square" rtlCol="0" anchor="ctr"/>
+          <a:lstStyle/>
           <a:p>
             <a:pPr marL="0" marR="0" lvl="0" indent="0" algn="l" defTabSz="914400" rtl="0" eaLnBrk="1" fontAlgn="auto" latinLnBrk="0" hangingPunct="1">
               <a:lnSpc>
-                <a:spcPct val="122000"/>
+                <a:spcPct val="100000"/>
               </a:lnSpc>
               <a:spcBef>
                 <a:spcPts val="0"/>
@@ -32641,16 +33281,16 @@
                   <a:noFill/>
                 </a:ln>
                 <a:solidFill>
-                  <a:srgbClr val="CFE8F3"/>
+                  <a:srgbClr val="6B5836"/>
                 </a:solidFill>
                 <a:effectLst/>
                 <a:uLnTx/>
                 <a:uFillTx/>
-                <a:latin typeface="Courier New" pitchFamily="34" charset="0"/>
-                <a:ea typeface="Courier New" pitchFamily="34" charset="-122"/>
-                <a:cs typeface="Courier New" pitchFamily="34" charset="-120"/>
-              </a:rPr>
-              <a:t>li.d  $a0, 1           # fd = stdout</a:t>
+                <a:latin typeface="Calibri" pitchFamily="34" charset="0"/>
+                <a:ea typeface="Calibri" pitchFamily="34" charset="-122"/>
+                <a:cs typeface="Calibri" pitchFamily="34" charset="-120"/>
+              </a:rPr>
+              <a:t>不同于普通函数调用约定：系统调用回来后，a0~a6 的值可能被破坏，不保证保留。</a:t>
             </a:r>
             <a:endParaRPr kumimoji="0" lang="en-US" sz="2400" b="0" i="0" u="none" strike="noStrike" kern="1200" cap="none" spc="0" normalizeH="0" baseline="0" noProof="0" dirty="0">
               <a:ln>
@@ -32667,10 +33307,32 @@
               <a:cs typeface="+mn-cs"/>
             </a:endParaRPr>
           </a:p>
-          <a:p>
-            <a:pPr marL="0" marR="0" lvl="0" indent="0" algn="l" defTabSz="914400" rtl="0" eaLnBrk="1" fontAlgn="auto" latinLnBrk="0" hangingPunct="1">
+        </p:txBody>
+      </p:sp>
+      <p:sp>
+        <p:nvSpPr>
+          <p:cNvPr id="16" name="Text 14"/>
+          <p:cNvSpPr/>
+          <p:nvPr/>
+        </p:nvSpPr>
+        <p:spPr>
+          <a:xfrm>
+            <a:off x="7132320" y="6355080"/>
+            <a:ext cx="4572000" cy="365760"/>
+          </a:xfrm>
+          <a:prstGeom prst="rect">
+            <a:avLst/>
+          </a:prstGeom>
+          <a:noFill/>
+          <a:ln/>
+        </p:spPr>
+        <p:txBody>
+          <a:bodyPr wrap="square" rtlCol="0" anchor="ctr"/>
+          <a:lstStyle/>
+          <a:p>
+            <a:pPr marL="0" marR="0" lvl="0" indent="0" algn="r" defTabSz="914400" rtl="0" eaLnBrk="1" fontAlgn="auto" latinLnBrk="0" hangingPunct="1">
               <a:lnSpc>
-                <a:spcPct val="122000"/>
+                <a:spcPct val="100000"/>
               </a:lnSpc>
               <a:spcBef>
                 <a:spcPts val="0"/>
@@ -32691,16 +33353,16 @@
                   <a:noFill/>
                 </a:ln>
                 <a:solidFill>
-                  <a:srgbClr val="CFE8F3"/>
+                  <a:srgbClr val="9AAABB"/>
                 </a:solidFill>
                 <a:effectLst/>
                 <a:uLnTx/>
                 <a:uFillTx/>
-                <a:latin typeface="Courier New" pitchFamily="34" charset="0"/>
-                <a:ea typeface="Courier New" pitchFamily="34" charset="-122"/>
-                <a:cs typeface="Courier New" pitchFamily="34" charset="-120"/>
-              </a:rPr>
-              <a:t>la.local $a1, .LC0     # 字符串地址</a:t>
+                <a:latin typeface="Calibri" pitchFamily="34" charset="0"/>
+                <a:ea typeface="Calibri" pitchFamily="34" charset="-122"/>
+                <a:cs typeface="Calibri" pitchFamily="34" charset="-120"/>
+              </a:rPr>
+              <a:t>ABI 介绍 · 下</a:t>
             </a:r>
             <a:endParaRPr kumimoji="0" lang="en-US" sz="2400" b="0" i="0" u="none" strike="noStrike" kern="1200" cap="none" spc="0" normalizeH="0" baseline="0" noProof="0" dirty="0">
               <a:ln>
@@ -32717,10 +33379,87 @@
               <a:cs typeface="+mn-cs"/>
             </a:endParaRPr>
           </a:p>
-          <a:p>
-            <a:pPr marL="0" marR="0" lvl="0" indent="0" algn="l" defTabSz="914400" rtl="0" eaLnBrk="1" fontAlgn="auto" latinLnBrk="0" hangingPunct="1">
+        </p:txBody>
+      </p:sp>
+    </p:spTree>
+  </p:cSld>
+  <p:clrMapOvr>
+    <a:masterClrMapping/>
+  </p:clrMapOvr>
+</p:sld>
+</file>
+
+<file path=ppt/slides/slide41.xml><?xml version="1.0" encoding="utf-8"?>
+<p:sld xmlns:a="http://schemas.openxmlformats.org/drawingml/2006/main" xmlns:r="http://schemas.openxmlformats.org/officeDocument/2006/relationships" xmlns:p="http://schemas.openxmlformats.org/presentationml/2006/main">
+  <p:cSld>
+    <p:bg>
+      <p:bgPr>
+        <a:solidFill>
+          <a:srgbClr val="F7FAFC"/>
+        </a:solidFill>
+        <a:effectLst/>
+      </p:bgPr>
+    </p:bg>
+    <p:spTree>
+      <p:nvGrpSpPr>
+        <p:cNvPr id="1" name=""/>
+        <p:cNvGrpSpPr/>
+        <p:nvPr/>
+      </p:nvGrpSpPr>
+      <p:grpSpPr>
+        <a:xfrm>
+          <a:off x="0" y="0"/>
+          <a:ext cx="0" cy="0"/>
+          <a:chOff x="0" y="0"/>
+          <a:chExt cx="0" cy="0"/>
+        </a:xfrm>
+      </p:grpSpPr>
+      <p:sp>
+        <p:nvSpPr>
+          <p:cNvPr id="2" name="Shape 0"/>
+          <p:cNvSpPr/>
+          <p:nvPr/>
+        </p:nvSpPr>
+        <p:spPr>
+          <a:xfrm>
+            <a:off x="457200" y="365760"/>
+            <a:ext cx="6035040" cy="502920"/>
+          </a:xfrm>
+          <a:prstGeom prst="roundRect">
+            <a:avLst>
+              <a:gd name="adj" fmla="val 49091"/>
+            </a:avLst>
+          </a:prstGeom>
+          <a:solidFill>
+            <a:srgbClr val="0A4A6E"/>
+          </a:solidFill>
+          <a:ln/>
+        </p:spPr>
+      </p:sp>
+      <p:sp>
+        <p:nvSpPr>
+          <p:cNvPr id="3" name="Text 1"/>
+          <p:cNvSpPr/>
+          <p:nvPr/>
+        </p:nvSpPr>
+        <p:spPr>
+          <a:xfrm>
+            <a:off x="457200" y="365760"/>
+            <a:ext cx="6035040" cy="502920"/>
+          </a:xfrm>
+          <a:prstGeom prst="rect">
+            <a:avLst/>
+          </a:prstGeom>
+          <a:noFill/>
+          <a:ln/>
+        </p:spPr>
+        <p:txBody>
+          <a:bodyPr wrap="square" rtlCol="0" anchor="ctr"/>
+          <a:lstStyle/>
+          <a:p>
+            <a:pPr marL="0" marR="0" lvl="0" indent="0" algn="ctr" defTabSz="914400" rtl="0" eaLnBrk="1" fontAlgn="auto" latinLnBrk="0" hangingPunct="1">
               <a:lnSpc>
-                <a:spcPct val="122000"/>
+                <a:spcPct val="100000"/>
               </a:lnSpc>
               <a:spcBef>
                 <a:spcPts val="0"/>
@@ -32736,21 +33475,21 @@
               <a:defRPr/>
             </a:pPr>
             <a:r>
-              <a:rPr kumimoji="0" lang="en-US" sz="2400" b="0" i="0" u="none" strike="noStrike" kern="1200" cap="none" spc="0" normalizeH="0" baseline="0" noProof="0" dirty="0">
+              <a:rPr kumimoji="0" lang="en-US" sz="2400" b="1" i="0" u="none" strike="noStrike" kern="1200" cap="none" spc="0" normalizeH="0" baseline="0" noProof="0" dirty="0">
                 <a:ln>
                   <a:noFill/>
                 </a:ln>
                 <a:solidFill>
-                  <a:srgbClr val="CFE8F3"/>
+                  <a:srgbClr val="FFFFFF"/>
                 </a:solidFill>
                 <a:effectLst/>
                 <a:uLnTx/>
                 <a:uFillTx/>
-                <a:latin typeface="Courier New" pitchFamily="34" charset="0"/>
-                <a:ea typeface="Courier New" pitchFamily="34" charset="-122"/>
-                <a:cs typeface="Courier New" pitchFamily="34" charset="-120"/>
-              </a:rPr>
-              <a:t>li.d  $a2, 12          # 字符串长度</a:t>
+                <a:latin typeface="Calibri" pitchFamily="34" charset="0"/>
+                <a:ea typeface="Calibri" pitchFamily="34" charset="-122"/>
+                <a:cs typeface="Calibri" pitchFamily="34" charset="-120"/>
+              </a:rPr>
+              <a:t>5.5 · 系统调用例子</a:t>
             </a:r>
             <a:endParaRPr kumimoji="0" lang="en-US" sz="2400" b="0" i="0" u="none" strike="noStrike" kern="1200" cap="none" spc="0" normalizeH="0" baseline="0" noProof="0" dirty="0">
               <a:ln>
@@ -32767,10 +33506,32 @@
               <a:cs typeface="+mn-cs"/>
             </a:endParaRPr>
           </a:p>
+        </p:txBody>
+      </p:sp>
+      <p:sp>
+        <p:nvSpPr>
+          <p:cNvPr id="4" name="Text 2"/>
+          <p:cNvSpPr/>
+          <p:nvPr/>
+        </p:nvSpPr>
+        <p:spPr>
+          <a:xfrm>
+            <a:off x="457200" y="932688"/>
+            <a:ext cx="11247120" cy="640080"/>
+          </a:xfrm>
+          <a:prstGeom prst="rect">
+            <a:avLst/>
+          </a:prstGeom>
+          <a:noFill/>
+          <a:ln/>
+        </p:spPr>
+        <p:txBody>
+          <a:bodyPr wrap="square" rtlCol="0" anchor="ctr"/>
+          <a:lstStyle/>
           <a:p>
             <a:pPr marL="0" marR="0" lvl="0" indent="0" algn="l" defTabSz="914400" rtl="0" eaLnBrk="1" fontAlgn="auto" latinLnBrk="0" hangingPunct="1">
               <a:lnSpc>
-                <a:spcPct val="122000"/>
+                <a:spcPct val="100000"/>
               </a:lnSpc>
               <a:spcBef>
                 <a:spcPts val="0"/>
@@ -32786,21 +33547,115 @@
               <a:defRPr/>
             </a:pPr>
             <a:r>
+              <a:rPr kumimoji="0" lang="en-US" sz="2800" b="1" i="0" u="none" strike="noStrike" kern="1200" cap="none" spc="0" normalizeH="0" baseline="0" noProof="0" dirty="0">
+                <a:ln>
+                  <a:noFill/>
+                </a:ln>
+                <a:solidFill>
+                  <a:srgbClr val="16222E"/>
+                </a:solidFill>
+                <a:effectLst/>
+                <a:uLnTx/>
+                <a:uFillTx/>
+                <a:latin typeface="Cambria" pitchFamily="34" charset="0"/>
+                <a:ea typeface="Cambria" pitchFamily="34" charset="-122"/>
+                <a:cs typeface="Cambria" pitchFamily="34" charset="-120"/>
+              </a:rPr>
+              <a:t>系统调用例子：sys_write 输出字符串</a:t>
+            </a:r>
+            <a:endParaRPr kumimoji="0" lang="en-US" sz="2800" b="0" i="0" u="none" strike="noStrike" kern="1200" cap="none" spc="0" normalizeH="0" baseline="0" noProof="0" dirty="0">
+              <a:ln>
+                <a:noFill/>
+              </a:ln>
+              <a:solidFill>
+                <a:prstClr val="black"/>
+              </a:solidFill>
+              <a:effectLst/>
+              <a:uLnTx/>
+              <a:uFillTx/>
+              <a:latin typeface="Calibri" panose="020F0502020204030204"/>
+              <a:ea typeface="+mn-ea"/>
+              <a:cs typeface="+mn-cs"/>
+            </a:endParaRPr>
+          </a:p>
+        </p:txBody>
+      </p:sp>
+      <p:sp>
+        <p:nvSpPr>
+          <p:cNvPr id="5" name="Shape 3"/>
+          <p:cNvSpPr/>
+          <p:nvPr/>
+        </p:nvSpPr>
+        <p:spPr>
+          <a:xfrm>
+            <a:off x="457200" y="1691640"/>
+            <a:ext cx="11247120" cy="640080"/>
+          </a:xfrm>
+          <a:prstGeom prst="roundRect">
+            <a:avLst>
+              <a:gd name="adj" fmla="val 14286"/>
+            </a:avLst>
+          </a:prstGeom>
+          <a:solidFill>
+            <a:srgbClr val="EAF3F8"/>
+          </a:solidFill>
+          <a:ln/>
+        </p:spPr>
+      </p:sp>
+      <p:sp>
+        <p:nvSpPr>
+          <p:cNvPr id="6" name="Text 4"/>
+          <p:cNvSpPr/>
+          <p:nvPr/>
+        </p:nvSpPr>
+        <p:spPr>
+          <a:xfrm>
+            <a:off x="731520" y="1691640"/>
+            <a:ext cx="10698480" cy="640080"/>
+          </a:xfrm>
+          <a:prstGeom prst="rect">
+            <a:avLst/>
+          </a:prstGeom>
+          <a:noFill/>
+          <a:ln/>
+        </p:spPr>
+        <p:txBody>
+          <a:bodyPr wrap="square" rtlCol="0" anchor="ctr"/>
+          <a:lstStyle/>
+          <a:p>
+            <a:pPr marL="0" marR="0" lvl="0" indent="0" algn="l" defTabSz="914400" rtl="0" eaLnBrk="1" fontAlgn="auto" latinLnBrk="0" hangingPunct="1">
+              <a:lnSpc>
+                <a:spcPct val="100000"/>
+              </a:lnSpc>
+              <a:spcBef>
+                <a:spcPts val="0"/>
+              </a:spcBef>
+              <a:spcAft>
+                <a:spcPts val="0"/>
+              </a:spcAft>
+              <a:buClrTx/>
+              <a:buSzTx/>
+              <a:buFontTx/>
+              <a:buNone/>
+              <a:tabLst/>
+              <a:defRPr/>
+            </a:pPr>
+            <a:r>
               <a:rPr kumimoji="0" lang="en-US" sz="2400" b="0" i="0" u="none" strike="noStrike" kern="1200" cap="none" spc="0" normalizeH="0" baseline="0" noProof="0" dirty="0">
                 <a:ln>
                   <a:noFill/>
                 </a:ln>
                 <a:solidFill>
-                  <a:srgbClr val="CFE8F3"/>
+                  <a:srgbClr val="16222E"/>
                 </a:solidFill>
                 <a:effectLst/>
                 <a:uLnTx/>
                 <a:uFillTx/>
-                <a:latin typeface="Courier New" pitchFamily="34" charset="0"/>
-                <a:ea typeface="Courier New" pitchFamily="34" charset="-122"/>
-                <a:cs typeface="Courier New" pitchFamily="34" charset="-120"/>
-              </a:rPr>
-              <a:t>syscall 0              # 系统调用</a:t>
+                <a:latin typeface="Calibri" pitchFamily="34" charset="0"/>
+                <a:ea typeface="Calibri" pitchFamily="34" charset="-122"/>
+                <a:cs typeface="Calibri" pitchFamily="34" charset="-120"/>
+              </a:rPr>
+              <a:t>sys_write 系统调用号是 64：fd=1（stdout）、字符串地址、字符串长度。</a:t>
             </a:r>
             <a:endParaRPr kumimoji="0" lang="en-US" sz="2400" b="0" i="0" u="none" strike="noStrike" kern="1200" cap="none" spc="0" normalizeH="0" baseline="0" noProof="0" dirty="0">
               <a:ln>
@@ -32821,41 +33676,43 @@
       </p:sp>
       <p:sp>
         <p:nvSpPr>
-          <p:cNvPr id="10" name="Shape 8"/>
-          <p:cNvSpPr/>
-          <p:nvPr/>
-        </p:nvSpPr>
-        <p:spPr>
-          <a:xfrm>
-            <a:off x="457200" y="5760720"/>
-            <a:ext cx="11247120" cy="548640"/>
+          <p:cNvPr id="7" name="Shape 5"/>
+          <p:cNvSpPr/>
+          <p:nvPr/>
+        </p:nvSpPr>
+        <p:spPr>
+          <a:xfrm>
+            <a:off x="457200" y="2377440"/>
+            <a:ext cx="11247120" cy="3246120"/>
           </a:xfrm>
           <a:prstGeom prst="roundRect">
             <a:avLst>
-              <a:gd name="adj" fmla="val 16667"/>
+              <a:gd name="adj" fmla="val 2254"/>
             </a:avLst>
           </a:prstGeom>
           <a:solidFill>
-            <a:srgbClr val="FFFFFF"/>
+            <a:srgbClr val="0B1E3B"/>
           </a:solidFill>
-          <a:ln w="12700">
-            <a:solidFill>
-              <a:srgbClr val="E1E9EF"/>
-            </a:solidFill>
-            <a:prstDash val="solid"/>
-          </a:ln>
-        </p:spPr>
-      </p:sp>
-      <p:sp>
-        <p:nvSpPr>
-          <p:cNvPr id="11" name="Text 9"/>
-          <p:cNvSpPr/>
-          <p:nvPr/>
-        </p:nvSpPr>
-        <p:spPr>
-          <a:xfrm>
-            <a:off x="685800" y="5760720"/>
-            <a:ext cx="10789920" cy="548640"/>
+          <a:ln/>
+          <a:effectLst>
+            <a:outerShdw blurRad="76200" dist="25400" dir="5400000" algn="bl" rotWithShape="0">
+              <a:srgbClr val="000000">
+                <a:alpha val="25000"/>
+              </a:srgbClr>
+            </a:outerShdw>
+          </a:effectLst>
+        </p:spPr>
+      </p:sp>
+      <p:sp>
+        <p:nvSpPr>
+          <p:cNvPr id="8" name="Text 6"/>
+          <p:cNvSpPr/>
+          <p:nvPr/>
+        </p:nvSpPr>
+        <p:spPr>
+          <a:xfrm>
+            <a:off x="713232" y="2523744"/>
+            <a:ext cx="10735056" cy="411480"/>
           </a:xfrm>
           <a:prstGeom prst="rect">
             <a:avLst/>
@@ -32885,12 +33742,12 @@
               <a:defRPr/>
             </a:pPr>
             <a:r>
-              <a:rPr kumimoji="0" lang="en-US" sz="2400" b="0" i="0" u="none" strike="noStrike" kern="1200" cap="none" spc="0" normalizeH="0" baseline="0" noProof="0" dirty="0">
+              <a:rPr kumimoji="0" lang="en-US" sz="2400" b="1" i="0" u="none" strike="noStrike" kern="1200" cap="none" spc="0" normalizeH="0" baseline="0" noProof="0" dirty="0">
                 <a:ln>
                   <a:noFill/>
                 </a:ln>
                 <a:solidFill>
-                  <a:srgbClr val="3E4E5C"/>
+                  <a:srgbClr val="F2A541"/>
                 </a:solidFill>
                 <a:effectLst/>
                 <a:uLnTx/>
@@ -32899,7 +33756,7 @@
                 <a:ea typeface="Calibri" pitchFamily="34" charset="-122"/>
                 <a:cs typeface="Calibri" pitchFamily="34" charset="-120"/>
               </a:rPr>
-              <a:t>运行结果：Hello World —— 完全没有调用 libc 的 printf，直接走内核接口。</a:t>
+              <a:t>syscall_test.S</a:t>
             </a:r>
             <a:endParaRPr kumimoji="0" lang="en-US" sz="2400" b="0" i="0" u="none" strike="noStrike" kern="1200" cap="none" spc="0" normalizeH="0" baseline="0" noProof="0" dirty="0">
               <a:ln>
@@ -32920,28 +33777,28 @@
       </p:sp>
       <p:sp>
         <p:nvSpPr>
-          <p:cNvPr id="12" name="Text 10"/>
-          <p:cNvSpPr/>
-          <p:nvPr/>
-        </p:nvSpPr>
-        <p:spPr>
-          <a:xfrm>
-            <a:off x="7132320" y="6355080"/>
-            <a:ext cx="4572000" cy="365760"/>
-          </a:xfrm>
-          <a:prstGeom prst="rect">
-            <a:avLst/>
-          </a:prstGeom>
-          <a:noFill/>
-          <a:ln/>
-        </p:spPr>
-        <p:txBody>
-          <a:bodyPr wrap="square" rtlCol="0" anchor="ctr"/>
-          <a:lstStyle/>
-          <a:p>
-            <a:pPr marL="0" marR="0" lvl="0" indent="0" algn="r" defTabSz="914400" rtl="0" eaLnBrk="1" fontAlgn="auto" latinLnBrk="0" hangingPunct="1">
+          <p:cNvPr id="9" name="Text 7"/>
+          <p:cNvSpPr/>
+          <p:nvPr/>
+        </p:nvSpPr>
+        <p:spPr>
+          <a:xfrm>
+            <a:off x="713232" y="2980944"/>
+            <a:ext cx="10735056" cy="2514600"/>
+          </a:xfrm>
+          <a:prstGeom prst="rect">
+            <a:avLst/>
+          </a:prstGeom>
+          <a:noFill/>
+          <a:ln/>
+        </p:spPr>
+        <p:txBody>
+          <a:bodyPr wrap="square" lIns="0" tIns="0" rIns="0" bIns="0" rtlCol="0" anchor="t"/>
+          <a:lstStyle/>
+          <a:p>
+            <a:pPr marL="0" marR="0" lvl="0" indent="0" algn="l" defTabSz="914400" rtl="0" eaLnBrk="1" fontAlgn="auto" latinLnBrk="0" hangingPunct="1">
               <a:lnSpc>
-                <a:spcPct val="100000"/>
+                <a:spcPct val="122000"/>
               </a:lnSpc>
               <a:spcBef>
                 <a:spcPts val="0"/>
@@ -32962,16 +33819,16 @@
                   <a:noFill/>
                 </a:ln>
                 <a:solidFill>
-                  <a:srgbClr val="9AAABB"/>
+                  <a:srgbClr val="CFE8F3"/>
                 </a:solidFill>
                 <a:effectLst/>
                 <a:uLnTx/>
                 <a:uFillTx/>
-                <a:latin typeface="Calibri" pitchFamily="34" charset="0"/>
-                <a:ea typeface="Calibri" pitchFamily="34" charset="-122"/>
-                <a:cs typeface="Calibri" pitchFamily="34" charset="-120"/>
-              </a:rPr>
-              <a:t>ABI 介绍 · 下</a:t>
+                <a:latin typeface="Courier New" pitchFamily="34" charset="0"/>
+                <a:ea typeface="Courier New" pitchFamily="34" charset="-122"/>
+                <a:cs typeface="Courier New" pitchFamily="34" charset="-120"/>
+              </a:rPr>
+              <a:t>li.d  $a7, 64          # sys_write 调用号</a:t>
             </a:r>
             <a:endParaRPr kumimoji="0" lang="en-US" sz="2400" b="0" i="0" u="none" strike="noStrike" kern="1200" cap="none" spc="0" normalizeH="0" baseline="0" noProof="0" dirty="0">
               <a:ln>
@@ -32988,6 +33845,377 @@
               <a:cs typeface="+mn-cs"/>
             </a:endParaRPr>
           </a:p>
+          <a:p>
+            <a:pPr marL="0" marR="0" lvl="0" indent="0" algn="l" defTabSz="914400" rtl="0" eaLnBrk="1" fontAlgn="auto" latinLnBrk="0" hangingPunct="1">
+              <a:lnSpc>
+                <a:spcPct val="122000"/>
+              </a:lnSpc>
+              <a:spcBef>
+                <a:spcPts val="0"/>
+              </a:spcBef>
+              <a:spcAft>
+                <a:spcPts val="0"/>
+              </a:spcAft>
+              <a:buClrTx/>
+              <a:buSzTx/>
+              <a:buFontTx/>
+              <a:buNone/>
+              <a:tabLst/>
+              <a:defRPr/>
+            </a:pPr>
+            <a:r>
+              <a:rPr kumimoji="0" lang="en-US" sz="2400" b="0" i="0" u="none" strike="noStrike" kern="1200" cap="none" spc="0" normalizeH="0" baseline="0" noProof="0" dirty="0">
+                <a:ln>
+                  <a:noFill/>
+                </a:ln>
+                <a:solidFill>
+                  <a:srgbClr val="CFE8F3"/>
+                </a:solidFill>
+                <a:effectLst/>
+                <a:uLnTx/>
+                <a:uFillTx/>
+                <a:latin typeface="Courier New" pitchFamily="34" charset="0"/>
+                <a:ea typeface="Courier New" pitchFamily="34" charset="-122"/>
+                <a:cs typeface="Courier New" pitchFamily="34" charset="-120"/>
+              </a:rPr>
+              <a:t>li.d  $a0, 1           # fd = stdout</a:t>
+            </a:r>
+            <a:endParaRPr kumimoji="0" lang="en-US" sz="2400" b="0" i="0" u="none" strike="noStrike" kern="1200" cap="none" spc="0" normalizeH="0" baseline="0" noProof="0" dirty="0">
+              <a:ln>
+                <a:noFill/>
+              </a:ln>
+              <a:solidFill>
+                <a:prstClr val="black"/>
+              </a:solidFill>
+              <a:effectLst/>
+              <a:uLnTx/>
+              <a:uFillTx/>
+              <a:latin typeface="Calibri" panose="020F0502020204030204"/>
+              <a:ea typeface="+mn-ea"/>
+              <a:cs typeface="+mn-cs"/>
+            </a:endParaRPr>
+          </a:p>
+          <a:p>
+            <a:pPr marL="0" marR="0" lvl="0" indent="0" algn="l" defTabSz="914400" rtl="0" eaLnBrk="1" fontAlgn="auto" latinLnBrk="0" hangingPunct="1">
+              <a:lnSpc>
+                <a:spcPct val="122000"/>
+              </a:lnSpc>
+              <a:spcBef>
+                <a:spcPts val="0"/>
+              </a:spcBef>
+              <a:spcAft>
+                <a:spcPts val="0"/>
+              </a:spcAft>
+              <a:buClrTx/>
+              <a:buSzTx/>
+              <a:buFontTx/>
+              <a:buNone/>
+              <a:tabLst/>
+              <a:defRPr/>
+            </a:pPr>
+            <a:r>
+              <a:rPr kumimoji="0" lang="en-US" sz="2400" b="0" i="0" u="none" strike="noStrike" kern="1200" cap="none" spc="0" normalizeH="0" baseline="0" noProof="0" dirty="0">
+                <a:ln>
+                  <a:noFill/>
+                </a:ln>
+                <a:solidFill>
+                  <a:srgbClr val="CFE8F3"/>
+                </a:solidFill>
+                <a:effectLst/>
+                <a:uLnTx/>
+                <a:uFillTx/>
+                <a:latin typeface="Courier New" pitchFamily="34" charset="0"/>
+                <a:ea typeface="Courier New" pitchFamily="34" charset="-122"/>
+                <a:cs typeface="Courier New" pitchFamily="34" charset="-120"/>
+              </a:rPr>
+              <a:t>la.local $a1, .LC0     # 字符串地址</a:t>
+            </a:r>
+            <a:endParaRPr kumimoji="0" lang="en-US" sz="2400" b="0" i="0" u="none" strike="noStrike" kern="1200" cap="none" spc="0" normalizeH="0" baseline="0" noProof="0" dirty="0">
+              <a:ln>
+                <a:noFill/>
+              </a:ln>
+              <a:solidFill>
+                <a:prstClr val="black"/>
+              </a:solidFill>
+              <a:effectLst/>
+              <a:uLnTx/>
+              <a:uFillTx/>
+              <a:latin typeface="Calibri" panose="020F0502020204030204"/>
+              <a:ea typeface="+mn-ea"/>
+              <a:cs typeface="+mn-cs"/>
+            </a:endParaRPr>
+          </a:p>
+          <a:p>
+            <a:pPr marL="0" marR="0" lvl="0" indent="0" algn="l" defTabSz="914400" rtl="0" eaLnBrk="1" fontAlgn="auto" latinLnBrk="0" hangingPunct="1">
+              <a:lnSpc>
+                <a:spcPct val="122000"/>
+              </a:lnSpc>
+              <a:spcBef>
+                <a:spcPts val="0"/>
+              </a:spcBef>
+              <a:spcAft>
+                <a:spcPts val="0"/>
+              </a:spcAft>
+              <a:buClrTx/>
+              <a:buSzTx/>
+              <a:buFontTx/>
+              <a:buNone/>
+              <a:tabLst/>
+              <a:defRPr/>
+            </a:pPr>
+            <a:r>
+              <a:rPr kumimoji="0" lang="en-US" sz="2400" b="0" i="0" u="none" strike="noStrike" kern="1200" cap="none" spc="0" normalizeH="0" baseline="0" noProof="0" dirty="0">
+                <a:ln>
+                  <a:noFill/>
+                </a:ln>
+                <a:solidFill>
+                  <a:srgbClr val="CFE8F3"/>
+                </a:solidFill>
+                <a:effectLst/>
+                <a:uLnTx/>
+                <a:uFillTx/>
+                <a:latin typeface="Courier New" pitchFamily="34" charset="0"/>
+                <a:ea typeface="Courier New" pitchFamily="34" charset="-122"/>
+                <a:cs typeface="Courier New" pitchFamily="34" charset="-120"/>
+              </a:rPr>
+              <a:t>li.d  $a2, 12          # 字符串长度</a:t>
+            </a:r>
+            <a:endParaRPr kumimoji="0" lang="en-US" sz="2400" b="0" i="0" u="none" strike="noStrike" kern="1200" cap="none" spc="0" normalizeH="0" baseline="0" noProof="0" dirty="0">
+              <a:ln>
+                <a:noFill/>
+              </a:ln>
+              <a:solidFill>
+                <a:prstClr val="black"/>
+              </a:solidFill>
+              <a:effectLst/>
+              <a:uLnTx/>
+              <a:uFillTx/>
+              <a:latin typeface="Calibri" panose="020F0502020204030204"/>
+              <a:ea typeface="+mn-ea"/>
+              <a:cs typeface="+mn-cs"/>
+            </a:endParaRPr>
+          </a:p>
+          <a:p>
+            <a:pPr marL="0" marR="0" lvl="0" indent="0" algn="l" defTabSz="914400" rtl="0" eaLnBrk="1" fontAlgn="auto" latinLnBrk="0" hangingPunct="1">
+              <a:lnSpc>
+                <a:spcPct val="122000"/>
+              </a:lnSpc>
+              <a:spcBef>
+                <a:spcPts val="0"/>
+              </a:spcBef>
+              <a:spcAft>
+                <a:spcPts val="0"/>
+              </a:spcAft>
+              <a:buClrTx/>
+              <a:buSzTx/>
+              <a:buFontTx/>
+              <a:buNone/>
+              <a:tabLst/>
+              <a:defRPr/>
+            </a:pPr>
+            <a:r>
+              <a:rPr kumimoji="0" lang="en-US" sz="2400" b="0" i="0" u="none" strike="noStrike" kern="1200" cap="none" spc="0" normalizeH="0" baseline="0" noProof="0" dirty="0">
+                <a:ln>
+                  <a:noFill/>
+                </a:ln>
+                <a:solidFill>
+                  <a:srgbClr val="CFE8F3"/>
+                </a:solidFill>
+                <a:effectLst/>
+                <a:uLnTx/>
+                <a:uFillTx/>
+                <a:latin typeface="Courier New" pitchFamily="34" charset="0"/>
+                <a:ea typeface="Courier New" pitchFamily="34" charset="-122"/>
+                <a:cs typeface="Courier New" pitchFamily="34" charset="-120"/>
+              </a:rPr>
+              <a:t>syscall 0              # 系统调用</a:t>
+            </a:r>
+            <a:endParaRPr kumimoji="0" lang="en-US" sz="2400" b="0" i="0" u="none" strike="noStrike" kern="1200" cap="none" spc="0" normalizeH="0" baseline="0" noProof="0" dirty="0">
+              <a:ln>
+                <a:noFill/>
+              </a:ln>
+              <a:solidFill>
+                <a:prstClr val="black"/>
+              </a:solidFill>
+              <a:effectLst/>
+              <a:uLnTx/>
+              <a:uFillTx/>
+              <a:latin typeface="Calibri" panose="020F0502020204030204"/>
+              <a:ea typeface="+mn-ea"/>
+              <a:cs typeface="+mn-cs"/>
+            </a:endParaRPr>
+          </a:p>
+        </p:txBody>
+      </p:sp>
+      <p:sp>
+        <p:nvSpPr>
+          <p:cNvPr id="10" name="Shape 8"/>
+          <p:cNvSpPr/>
+          <p:nvPr/>
+        </p:nvSpPr>
+        <p:spPr>
+          <a:xfrm>
+            <a:off x="457200" y="5760720"/>
+            <a:ext cx="11247120" cy="548640"/>
+          </a:xfrm>
+          <a:prstGeom prst="roundRect">
+            <a:avLst>
+              <a:gd name="adj" fmla="val 16667"/>
+            </a:avLst>
+          </a:prstGeom>
+          <a:solidFill>
+            <a:srgbClr val="FFFFFF"/>
+          </a:solidFill>
+          <a:ln w="12700">
+            <a:solidFill>
+              <a:srgbClr val="E1E9EF"/>
+            </a:solidFill>
+            <a:prstDash val="solid"/>
+          </a:ln>
+        </p:spPr>
+      </p:sp>
+      <p:sp>
+        <p:nvSpPr>
+          <p:cNvPr id="11" name="Text 9"/>
+          <p:cNvSpPr/>
+          <p:nvPr/>
+        </p:nvSpPr>
+        <p:spPr>
+          <a:xfrm>
+            <a:off x="685800" y="5760720"/>
+            <a:ext cx="10789920" cy="548640"/>
+          </a:xfrm>
+          <a:prstGeom prst="rect">
+            <a:avLst/>
+          </a:prstGeom>
+          <a:noFill/>
+          <a:ln/>
+        </p:spPr>
+        <p:txBody>
+          <a:bodyPr wrap="square" rtlCol="0" anchor="ctr"/>
+          <a:lstStyle/>
+          <a:p>
+            <a:pPr marL="0" marR="0" lvl="0" indent="0" algn="l" defTabSz="914400" rtl="0" eaLnBrk="1" fontAlgn="auto" latinLnBrk="0" hangingPunct="1">
+              <a:lnSpc>
+                <a:spcPct val="100000"/>
+              </a:lnSpc>
+              <a:spcBef>
+                <a:spcPts val="0"/>
+              </a:spcBef>
+              <a:spcAft>
+                <a:spcPts val="0"/>
+              </a:spcAft>
+              <a:buClrTx/>
+              <a:buSzTx/>
+              <a:buFontTx/>
+              <a:buNone/>
+              <a:tabLst/>
+              <a:defRPr/>
+            </a:pPr>
+            <a:r>
+              <a:rPr kumimoji="0" lang="en-US" sz="2400" b="0" i="0" u="none" strike="noStrike" kern="1200" cap="none" spc="0" normalizeH="0" baseline="0" noProof="0" dirty="0">
+                <a:ln>
+                  <a:noFill/>
+                </a:ln>
+                <a:solidFill>
+                  <a:srgbClr val="3E4E5C"/>
+                </a:solidFill>
+                <a:effectLst/>
+                <a:uLnTx/>
+                <a:uFillTx/>
+                <a:latin typeface="Calibri" pitchFamily="34" charset="0"/>
+                <a:ea typeface="Calibri" pitchFamily="34" charset="-122"/>
+                <a:cs typeface="Calibri" pitchFamily="34" charset="-120"/>
+              </a:rPr>
+              <a:t>运行结果：Hello World —— 完全没有调用 libc 的 printf，直接走内核接口。</a:t>
+            </a:r>
+            <a:endParaRPr kumimoji="0" lang="en-US" sz="2400" b="0" i="0" u="none" strike="noStrike" kern="1200" cap="none" spc="0" normalizeH="0" baseline="0" noProof="0" dirty="0">
+              <a:ln>
+                <a:noFill/>
+              </a:ln>
+              <a:solidFill>
+                <a:prstClr val="black"/>
+              </a:solidFill>
+              <a:effectLst/>
+              <a:uLnTx/>
+              <a:uFillTx/>
+              <a:latin typeface="Calibri" panose="020F0502020204030204"/>
+              <a:ea typeface="+mn-ea"/>
+              <a:cs typeface="+mn-cs"/>
+            </a:endParaRPr>
+          </a:p>
+        </p:txBody>
+      </p:sp>
+      <p:sp>
+        <p:nvSpPr>
+          <p:cNvPr id="12" name="Text 10"/>
+          <p:cNvSpPr/>
+          <p:nvPr/>
+        </p:nvSpPr>
+        <p:spPr>
+          <a:xfrm>
+            <a:off x="7132320" y="6355080"/>
+            <a:ext cx="4572000" cy="365760"/>
+          </a:xfrm>
+          <a:prstGeom prst="rect">
+            <a:avLst/>
+          </a:prstGeom>
+          <a:noFill/>
+          <a:ln/>
+        </p:spPr>
+        <p:txBody>
+          <a:bodyPr wrap="square" rtlCol="0" anchor="ctr"/>
+          <a:lstStyle/>
+          <a:p>
+            <a:pPr marL="0" marR="0" lvl="0" indent="0" algn="r" defTabSz="914400" rtl="0" eaLnBrk="1" fontAlgn="auto" latinLnBrk="0" hangingPunct="1">
+              <a:lnSpc>
+                <a:spcPct val="100000"/>
+              </a:lnSpc>
+              <a:spcBef>
+                <a:spcPts val="0"/>
+              </a:spcBef>
+              <a:spcAft>
+                <a:spcPts val="0"/>
+              </a:spcAft>
+              <a:buClrTx/>
+              <a:buSzTx/>
+              <a:buFontTx/>
+              <a:buNone/>
+              <a:tabLst/>
+              <a:defRPr/>
+            </a:pPr>
+            <a:r>
+              <a:rPr kumimoji="0" lang="en-US" sz="2400" b="0" i="0" u="none" strike="noStrike" kern="1200" cap="none" spc="0" normalizeH="0" baseline="0" noProof="0" dirty="0">
+                <a:ln>
+                  <a:noFill/>
+                </a:ln>
+                <a:solidFill>
+                  <a:srgbClr val="9AAABB"/>
+                </a:solidFill>
+                <a:effectLst/>
+                <a:uLnTx/>
+                <a:uFillTx/>
+                <a:latin typeface="Calibri" pitchFamily="34" charset="0"/>
+                <a:ea typeface="Calibri" pitchFamily="34" charset="-122"/>
+                <a:cs typeface="Calibri" pitchFamily="34" charset="-120"/>
+              </a:rPr>
+              <a:t>ABI 介绍 · 下</a:t>
+            </a:r>
+            <a:endParaRPr kumimoji="0" lang="en-US" sz="2400" b="0" i="0" u="none" strike="noStrike" kern="1200" cap="none" spc="0" normalizeH="0" baseline="0" noProof="0" dirty="0">
+              <a:ln>
+                <a:noFill/>
+              </a:ln>
+              <a:solidFill>
+                <a:prstClr val="black"/>
+              </a:solidFill>
+              <a:effectLst/>
+              <a:uLnTx/>
+              <a:uFillTx/>
+              <a:latin typeface="Calibri" panose="020F0502020204030204"/>
+              <a:ea typeface="+mn-ea"/>
+              <a:cs typeface="+mn-cs"/>
+            </a:endParaRPr>
+          </a:p>
         </p:txBody>
       </p:sp>
     </p:spTree>
@@ -32998,7 +34226,7 @@
 </p:sld>
 </file>
 
-<file path=ppt/slides/slide41.xml><?xml version="1.0" encoding="utf-8"?>
+<file path=ppt/slides/slide42.xml><?xml version="1.0" encoding="utf-8"?>
 <p:sld xmlns:a="http://schemas.openxmlformats.org/drawingml/2006/main" xmlns:r="http://schemas.openxmlformats.org/officeDocument/2006/relationships" xmlns:p="http://schemas.openxmlformats.org/presentationml/2006/main">
   <p:cSld>
     <p:bg>
@@ -35808,45 +37036,6 @@
           </a:p>
         </p:txBody>
       </p:sp>
-      <p:sp>
-        <p:nvSpPr>
-          <p:cNvPr id="37" name="Text 35"/>
-          <p:cNvSpPr/>
-          <p:nvPr/>
-        </p:nvSpPr>
-        <p:spPr>
-          <a:xfrm>
-            <a:off x="7132320" y="6355080"/>
-            <a:ext cx="4572000" cy="365760"/>
-          </a:xfrm>
-          <a:prstGeom prst="rect">
-            <a:avLst/>
-          </a:prstGeom>
-          <a:noFill/>
-          <a:ln/>
-        </p:spPr>
-        <p:txBody>
-          <a:bodyPr wrap="square" rtlCol="0" anchor="ctr"/>
-          <a:lstStyle/>
-          <a:p>
-            <a:pPr marL="0" indent="0" algn="r">
-              <a:buNone/>
-            </a:pPr>
-            <a:r>
-              <a:rPr lang="en-US" sz="2400" dirty="0">
-                <a:solidFill>
-                  <a:srgbClr val="9AAABB"/>
-                </a:solidFill>
-                <a:latin typeface="Calibri" pitchFamily="34" charset="0"/>
-                <a:ea typeface="Calibri" pitchFamily="34" charset="-122"/>
-                <a:cs typeface="Calibri" pitchFamily="34" charset="-120"/>
-              </a:rPr>
-              <a:t>ABI 介绍 · 上</a:t>
-            </a:r>
-            <a:endParaRPr lang="en-US" sz="2400" dirty="0"/>
-          </a:p>
-        </p:txBody>
-      </p:sp>
     </p:spTree>
   </p:cSld>
   <p:clrMapOvr>
@@ -37342,78 +38531,6 @@
             <a:prstDash val="solid"/>
           </a:ln>
         </p:spPr>
-      </p:sp>
-      <p:sp>
-        <p:nvSpPr>
-          <p:cNvPr id="9" name="Text 7"/>
-          <p:cNvSpPr/>
-          <p:nvPr/>
-        </p:nvSpPr>
-        <p:spPr>
-          <a:xfrm>
-            <a:off x="640080" y="4617720"/>
-            <a:ext cx="10698480" cy="1188720"/>
-          </a:xfrm>
-          <a:prstGeom prst="rect">
-            <a:avLst/>
-          </a:prstGeom>
-          <a:noFill/>
-          <a:ln/>
-        </p:spPr>
-        <p:txBody>
-          <a:bodyPr wrap="square" rtlCol="0" anchor="ctr"/>
-          <a:lstStyle/>
-          <a:p>
-            <a:pPr marL="0" marR="0" lvl="0" indent="0" algn="l" defTabSz="914400" rtl="0" eaLnBrk="1" fontAlgn="auto" latinLnBrk="0" hangingPunct="1">
-              <a:lnSpc>
-                <a:spcPct val="130000"/>
-              </a:lnSpc>
-              <a:spcBef>
-                <a:spcPts val="0"/>
-              </a:spcBef>
-              <a:spcAft>
-                <a:spcPts val="0"/>
-              </a:spcAft>
-              <a:buClrTx/>
-              <a:buSzTx/>
-              <a:buFontTx/>
-              <a:buNone/>
-              <a:tabLst/>
-              <a:defRPr/>
-            </a:pPr>
-            <a:r>
-              <a:rPr kumimoji="0" lang="en-US" sz="2400" b="0" i="0" u="none" strike="noStrike" kern="1200" cap="none" spc="0" normalizeH="0" baseline="0" noProof="0" dirty="0">
-                <a:ln>
-                  <a:noFill/>
-                </a:ln>
-                <a:solidFill>
-                  <a:srgbClr val="C7DAE6"/>
-                </a:solidFill>
-                <a:effectLst/>
-                <a:uLnTx/>
-                <a:uFillTx/>
-                <a:latin typeface="Calibri" pitchFamily="34" charset="0"/>
-                <a:ea typeface="Calibri" pitchFamily="34" charset="-122"/>
-                <a:cs typeface="Calibri" pitchFamily="34" charset="-120"/>
-              </a:rPr>
-              <a:t>本课件内容：两道思考题 + 完整答案推导，讲清楚“选小类型”和“声明顺序”这两条经验为什么必须一起用。</a:t>
-            </a:r>
-            <a:endParaRPr kumimoji="0" lang="en-US" sz="2400" b="0" i="0" u="none" strike="noStrike" kern="1200" cap="none" spc="0" normalizeH="0" baseline="0" noProof="0" dirty="0">
-              <a:ln>
-                <a:noFill/>
-              </a:ln>
-              <a:solidFill>
-                <a:prstClr val="black"/>
-              </a:solidFill>
-              <a:effectLst/>
-              <a:uLnTx/>
-              <a:uFillTx/>
-              <a:latin typeface="Calibri" panose="020F0502020204030204"/>
-              <a:ea typeface="+mn-ea"/>
-              <a:cs typeface="+mn-cs"/>
-            </a:endParaRPr>
-          </a:p>
-        </p:txBody>
       </p:sp>
     </p:spTree>
   </p:cSld>

</xml_diff>